<commit_message>
Update presentation and PDF with competitive analysis and new flowchart
Update Cisco case presentation and PDF to include competitive analysis, Perceive-Reason-Act architecture, and a new detailed engineering flowchart.

Replit-Commit-Author: Agent
Replit-Commit-Session-Id: d1af01ac-c843-4bff-a7a9-fedef4198273
Replit-Commit-Checkpoint-Type: full_checkpoint
Replit-Commit-Event-Id: 55b4aeeb-7a71-4844-b074-6bfc9edfd9f9
Replit-Helium-Checkpoint-Created: true
</commit_message>
<xml_diff>
--- a/cisco_case/Cisco_Webex_AI_Presentation.pptx
+++ b/cisco_case/Cisco_Webex_AI_Presentation.pptx
@@ -30,6 +30,7 @@
     <p:sldId id="278" r:id="rId29"/>
     <p:sldId id="279" r:id="rId30"/>
     <p:sldId id="280" r:id="rId31"/>
+    <p:sldId id="281" r:id="rId32"/>
   </p:sldIdLst>
   <p:sldSz cx="9144000" cy="6858000" type="screen4x3"/>
   <p:notesSz cx="6858000" cy="9144000"/>
@@ -3408,7 +3409,7 @@
               </a:defRPr>
             </a:pPr>
             <a:r>
-              <a:t>Problem-Solution Flowchart</a:t>
+              <a:t>Workflow Orchestrator Agent: Technical Flowchart</a:t>
             </a:r>
           </a:p>
           <a:p>
@@ -3420,7 +3421,7 @@
               </a:defRPr>
             </a:pPr>
             <a:r>
-              <a:t>From Root Causes to Agentic AI Solutions</a:t>
+              <a:t>Perceive - Reason - Act Loop | Swimlane Architecture</a:t>
             </a:r>
           </a:p>
         </p:txBody>
@@ -3484,8 +3485,8 @@
         </p:blipFill>
         <p:spPr>
           <a:xfrm>
-            <a:off x="182880" y="1188720"/>
-            <a:ext cx="8778240" cy="5486400"/>
+            <a:off x="91440" y="1143000"/>
+            <a:ext cx="8961120" cy="5577840"/>
           </a:xfrm>
           <a:prstGeom prst="rect">
             <a:avLst/>
@@ -3565,7 +3566,7 @@
               </a:defRPr>
             </a:pPr>
             <a:r>
-              <a:t>Recommendation Overview</a:t>
+              <a:t>Competitive Analysis: How Webex Leapfrogs</a:t>
             </a:r>
           </a:p>
           <a:p>
@@ -3577,7 +3578,7 @@
               </a:defRPr>
             </a:pPr>
             <a:r>
-              <a:t>Three Solutions to Make Webex the Agentic Collaboration Leader</a:t>
+              <a:t>Why Teams &amp; Zoom Lead Today + Webex's Agentic Advantage</a:t>
             </a:r>
           </a:p>
         </p:txBody>
@@ -3625,341 +3626,30 @@
           </a:p>
         </p:txBody>
       </p:sp>
-      <p:sp>
-        <p:nvSpPr>
-          <p:cNvPr id="4" name="Rounded Rectangle 3"/>
-          <p:cNvSpPr/>
+      <p:pic>
+        <p:nvPicPr>
+          <p:cNvPr id="4" name="Picture 3" descr="competitive_advantage.png"/>
+          <p:cNvPicPr>
+            <a:picLocks noChangeAspect="1"/>
+          </p:cNvPicPr>
           <p:nvPr/>
-        </p:nvSpPr>
-        <p:spPr>
-          <a:xfrm>
-            <a:off x="457200" y="1463040"/>
-            <a:ext cx="2560320" cy="4114800"/>
-          </a:xfrm>
-          <a:prstGeom prst="roundRect">
-            <a:avLst/>
-          </a:prstGeom>
-          <a:solidFill>
-            <a:srgbClr val="F5FFF5"/>
-          </a:solidFill>
-          <a:ln w="25400">
-            <a:solidFill>
-              <a:srgbClr val="27AE60"/>
-            </a:solidFill>
-          </a:ln>
-        </p:spPr>
-        <p:style>
-          <a:lnRef idx="1">
-            <a:schemeClr val="accent1"/>
-          </a:lnRef>
-          <a:fillRef idx="3">
-            <a:schemeClr val="accent1"/>
-          </a:fillRef>
-          <a:effectRef idx="2">
-            <a:schemeClr val="accent1"/>
-          </a:effectRef>
-          <a:fontRef idx="minor">
-            <a:schemeClr val="lt1"/>
-          </a:fontRef>
-        </p:style>
-        <p:txBody>
-          <a:bodyPr rtlCol="0" anchor="ctr" wrap="square" lIns="137160" rIns="137160"/>
-          <a:lstStyle/>
-          <a:p>
-            <a:pPr algn="ctr">
-              <a:defRPr sz="1400" b="1">
-                <a:solidFill>
-                  <a:srgbClr val="27AE60"/>
-                </a:solidFill>
-              </a:defRPr>
-            </a:pPr>
-            <a:r>
-              <a:t>Solution 1</a:t>
-            </a:r>
-          </a:p>
-          <a:p>
-            <a:pPr>
-              <a:defRPr sz="400"/>
-            </a:pPr>
-          </a:p>
-          <a:p>
-            <a:pPr algn="ctr">
-              <a:defRPr sz="1400" b="1">
-                <a:solidFill>
-                  <a:srgbClr val="002060"/>
-                </a:solidFill>
-              </a:defRPr>
-            </a:pPr>
-            <a:r>
-              <a:t>Agentic AI</a:t>
-            </a:r>
-            <a:br/>
-            <a:r>
-              <a:t>Transformation</a:t>
-            </a:r>
-          </a:p>
-          <a:p>
-            <a:pPr>
-              <a:defRPr sz="800"/>
-            </a:pPr>
-          </a:p>
-          <a:p>
-            <a:pPr algn="ctr">
-              <a:defRPr sz="1100">
-                <a:solidFill>
-                  <a:srgbClr val="323232"/>
-                </a:solidFill>
-              </a:defRPr>
-            </a:pPr>
-            <a:r>
-              <a:t>AI that WORKS, not just assists.</a:t>
-            </a:r>
-            <a:br/>
-            <a:r>
-              <a:t>Autonomous task execution:</a:t>
-            </a:r>
-            <a:br/>
-            <a:r>
-              <a:t>schedule, draft, assign, follow up</a:t>
-            </a:r>
-          </a:p>
-        </p:txBody>
-      </p:sp>
-      <p:sp>
-        <p:nvSpPr>
-          <p:cNvPr id="5" name="Rounded Rectangle 4"/>
-          <p:cNvSpPr/>
-          <p:nvPr/>
-        </p:nvSpPr>
-        <p:spPr>
-          <a:xfrm>
-            <a:off x="3291840" y="1463040"/>
-            <a:ext cx="2560320" cy="4114800"/>
-          </a:xfrm>
-          <a:prstGeom prst="roundRect">
-            <a:avLst/>
-          </a:prstGeom>
-          <a:solidFill>
-            <a:srgbClr val="F5FFF5"/>
-          </a:solidFill>
-          <a:ln w="25400">
-            <a:solidFill>
-              <a:srgbClr val="004FA9"/>
-            </a:solidFill>
-          </a:ln>
-        </p:spPr>
-        <p:style>
-          <a:lnRef idx="1">
-            <a:schemeClr val="accent1"/>
-          </a:lnRef>
-          <a:fillRef idx="3">
-            <a:schemeClr val="accent1"/>
-          </a:fillRef>
-          <a:effectRef idx="2">
-            <a:schemeClr val="accent1"/>
-          </a:effectRef>
-          <a:fontRef idx="minor">
-            <a:schemeClr val="lt1"/>
-          </a:fontRef>
-        </p:style>
-        <p:txBody>
-          <a:bodyPr rtlCol="0" anchor="ctr" wrap="square" lIns="137160" rIns="137160"/>
-          <a:lstStyle/>
-          <a:p>
-            <a:pPr algn="ctr">
-              <a:defRPr sz="1400" b="1">
-                <a:solidFill>
-                  <a:srgbClr val="004FA9"/>
-                </a:solidFill>
-              </a:defRPr>
-            </a:pPr>
-            <a:r>
-              <a:t>Solution 2</a:t>
-            </a:r>
-          </a:p>
-          <a:p>
-            <a:pPr>
-              <a:defRPr sz="400"/>
-            </a:pPr>
-          </a:p>
-          <a:p>
-            <a:pPr algn="ctr">
-              <a:defRPr sz="1400" b="1">
-                <a:solidFill>
-                  <a:srgbClr val="002060"/>
-                </a:solidFill>
-              </a:defRPr>
-            </a:pPr>
-            <a:r>
-              <a:t>Webex AI Agent</a:t>
-            </a:r>
-            <a:br/>
-            <a:r>
-              <a:t>Platform (SDK)</a:t>
-            </a:r>
-          </a:p>
-          <a:p>
-            <a:pPr>
-              <a:defRPr sz="800"/>
-            </a:pPr>
-          </a:p>
-          <a:p>
-            <a:pPr algn="ctr">
-              <a:defRPr sz="1100">
-                <a:solidFill>
-                  <a:srgbClr val="323232"/>
-                </a:solidFill>
-              </a:defRPr>
-            </a:pPr>
-            <a:r>
-              <a:t>Open developer framework for</a:t>
-            </a:r>
-            <a:br/>
-            <a:r>
-              <a:t>vertical-specific AI agents.</a:t>
-            </a:r>
-            <a:br/>
-            <a:r>
-              <a:t>Agent marketplace ecosystem</a:t>
-            </a:r>
-          </a:p>
-        </p:txBody>
-      </p:sp>
-      <p:sp>
-        <p:nvSpPr>
-          <p:cNvPr id="6" name="Rounded Rectangle 5"/>
-          <p:cNvSpPr/>
-          <p:nvPr/>
-        </p:nvSpPr>
-        <p:spPr>
-          <a:xfrm>
-            <a:off x="6126480" y="1463040"/>
-            <a:ext cx="2560320" cy="4114800"/>
-          </a:xfrm>
-          <a:prstGeom prst="roundRect">
-            <a:avLst/>
-          </a:prstGeom>
-          <a:solidFill>
-            <a:srgbClr val="F5FFF5"/>
-          </a:solidFill>
-          <a:ln w="25400">
-            <a:solidFill>
-              <a:srgbClr val="F39C12"/>
-            </a:solidFill>
-          </a:ln>
-        </p:spPr>
-        <p:style>
-          <a:lnRef idx="1">
-            <a:schemeClr val="accent1"/>
-          </a:lnRef>
-          <a:fillRef idx="3">
-            <a:schemeClr val="accent1"/>
-          </a:fillRef>
-          <a:effectRef idx="2">
-            <a:schemeClr val="accent1"/>
-          </a:effectRef>
-          <a:fontRef idx="minor">
-            <a:schemeClr val="lt1"/>
-          </a:fontRef>
-        </p:style>
-        <p:txBody>
-          <a:bodyPr rtlCol="0" anchor="ctr" wrap="square" lIns="137160" rIns="137160"/>
-          <a:lstStyle/>
-          <a:p>
-            <a:pPr algn="ctr">
-              <a:defRPr sz="1400" b="1">
-                <a:solidFill>
-                  <a:srgbClr val="F39C12"/>
-                </a:solidFill>
-              </a:defRPr>
-            </a:pPr>
-            <a:r>
-              <a:t>Solution 3</a:t>
-            </a:r>
-          </a:p>
-          <a:p>
-            <a:pPr>
-              <a:defRPr sz="400"/>
-            </a:pPr>
-          </a:p>
-          <a:p>
-            <a:pPr algn="ctr">
-              <a:defRPr sz="1400" b="1">
-                <a:solidFill>
-                  <a:srgbClr val="002060"/>
-                </a:solidFill>
-              </a:defRPr>
-            </a:pPr>
-            <a:r>
-              <a:t>Intelligent Workflow</a:t>
-            </a:r>
-            <a:br/>
-            <a:r>
-              <a:t>Engine</a:t>
-            </a:r>
-          </a:p>
-          <a:p>
-            <a:pPr>
-              <a:defRPr sz="800"/>
-            </a:pPr>
-          </a:p>
-          <a:p>
-            <a:pPr algn="ctr">
-              <a:defRPr sz="1100">
-                <a:solidFill>
-                  <a:srgbClr val="323232"/>
-                </a:solidFill>
-              </a:defRPr>
-            </a:pPr>
-            <a:r>
-              <a:t>200+ enterprise integrations.</a:t>
-            </a:r>
-            <a:br/>
-            <a:r>
-              <a:t>AI-powered cross-platform</a:t>
-            </a:r>
-            <a:br/>
-            <a:r>
-              <a:t>workflow automation</a:t>
-            </a:r>
-          </a:p>
-        </p:txBody>
-      </p:sp>
-      <p:sp>
-        <p:nvSpPr>
-          <p:cNvPr id="7" name="TextBox 6"/>
-          <p:cNvSpPr txBox="1"/>
-          <p:nvPr/>
-        </p:nvSpPr>
-        <p:spPr>
-          <a:xfrm>
-            <a:off x="274320" y="6400800"/>
-            <a:ext cx="8595360" cy="365760"/>
+        </p:nvPicPr>
+        <p:blipFill>
+          <a:blip r:embed="rId2"/>
+          <a:stretch>
+            <a:fillRect/>
+          </a:stretch>
+        </p:blipFill>
+        <p:spPr>
+          <a:xfrm>
+            <a:off x="91440" y="1143000"/>
+            <a:ext cx="8961120" cy="5577840"/>
           </a:xfrm>
           <a:prstGeom prst="rect">
             <a:avLst/>
           </a:prstGeom>
-          <a:noFill/>
-        </p:spPr>
-        <p:txBody>
-          <a:bodyPr wrap="none">
-            <a:spAutoFit/>
-          </a:bodyPr>
-          <a:lstStyle/>
-          <a:p>
-            <a:pPr algn="ctr">
-              <a:defRPr sz="800">
-                <a:solidFill>
-                  <a:srgbClr val="969696"/>
-                </a:solidFill>
-              </a:defRPr>
-            </a:pPr>
-            <a:r>
-              <a:t>Industry Analysis | Problem Identification | Recommendations | Implementation | Financials | Risks | Executive Summary</a:t>
-            </a:r>
-          </a:p>
-        </p:txBody>
-      </p:sp>
+        </p:spPr>
+      </p:pic>
     </p:spTree>
   </p:cSld>
   <p:clrMapOvr>
@@ -4033,7 +3723,7 @@
               </a:defRPr>
             </a:pPr>
             <a:r>
-              <a:t>Solution 1: Agentic AI Transformation</a:t>
+              <a:t>Recommendation Overview</a:t>
             </a:r>
           </a:p>
           <a:p>
@@ -4045,7 +3735,7 @@
               </a:defRPr>
             </a:pPr>
             <a:r>
-              <a:t>Evolving from Assistant to Autonomous Agent</a:t>
+              <a:t>Three Solutions to Make Webex the Agentic Collaboration Leader</a:t>
             </a:r>
           </a:p>
         </p:txBody>
@@ -4093,33 +3783,309 @@
           </a:p>
         </p:txBody>
       </p:sp>
-      <p:pic>
-        <p:nvPicPr>
-          <p:cNvPr id="4" name="Picture 3" descr="agentic_evolution.png"/>
-          <p:cNvPicPr>
-            <a:picLocks noChangeAspect="1"/>
-          </p:cNvPicPr>
+      <p:sp>
+        <p:nvSpPr>
+          <p:cNvPr id="4" name="Rounded Rectangle 3"/>
+          <p:cNvSpPr/>
           <p:nvPr/>
-        </p:nvPicPr>
-        <p:blipFill>
-          <a:blip r:embed="rId2"/>
-          <a:stretch>
-            <a:fillRect/>
-          </a:stretch>
-        </p:blipFill>
-        <p:spPr>
-          <a:xfrm>
-            <a:off x="274320" y="1280160"/>
-            <a:ext cx="8595360" cy="5029200"/>
-          </a:xfrm>
-          <a:prstGeom prst="rect">
+        </p:nvSpPr>
+        <p:spPr>
+          <a:xfrm>
+            <a:off x="457200" y="1463040"/>
+            <a:ext cx="2560320" cy="4114800"/>
+          </a:xfrm>
+          <a:prstGeom prst="roundRect">
             <a:avLst/>
           </a:prstGeom>
-        </p:spPr>
-      </p:pic>
-      <p:sp>
-        <p:nvSpPr>
-          <p:cNvPr id="5" name="TextBox 4"/>
+          <a:solidFill>
+            <a:srgbClr val="F5FFF5"/>
+          </a:solidFill>
+          <a:ln w="25400">
+            <a:solidFill>
+              <a:srgbClr val="27AE60"/>
+            </a:solidFill>
+          </a:ln>
+        </p:spPr>
+        <p:style>
+          <a:lnRef idx="1">
+            <a:schemeClr val="accent1"/>
+          </a:lnRef>
+          <a:fillRef idx="3">
+            <a:schemeClr val="accent1"/>
+          </a:fillRef>
+          <a:effectRef idx="2">
+            <a:schemeClr val="accent1"/>
+          </a:effectRef>
+          <a:fontRef idx="minor">
+            <a:schemeClr val="lt1"/>
+          </a:fontRef>
+        </p:style>
+        <p:txBody>
+          <a:bodyPr rtlCol="0" anchor="ctr" wrap="square" lIns="137160" rIns="137160"/>
+          <a:lstStyle/>
+          <a:p>
+            <a:pPr algn="ctr">
+              <a:defRPr sz="1400" b="1">
+                <a:solidFill>
+                  <a:srgbClr val="27AE60"/>
+                </a:solidFill>
+              </a:defRPr>
+            </a:pPr>
+            <a:r>
+              <a:t>Solution 1</a:t>
+            </a:r>
+          </a:p>
+          <a:p>
+            <a:pPr>
+              <a:defRPr sz="400"/>
+            </a:pPr>
+          </a:p>
+          <a:p>
+            <a:pPr algn="ctr">
+              <a:defRPr sz="1400" b="1">
+                <a:solidFill>
+                  <a:srgbClr val="002060"/>
+                </a:solidFill>
+              </a:defRPr>
+            </a:pPr>
+            <a:r>
+              <a:t>Agentic AI</a:t>
+            </a:r>
+            <a:br/>
+            <a:r>
+              <a:t>Transformation</a:t>
+            </a:r>
+          </a:p>
+          <a:p>
+            <a:pPr>
+              <a:defRPr sz="800"/>
+            </a:pPr>
+          </a:p>
+          <a:p>
+            <a:pPr algn="ctr">
+              <a:defRPr sz="1100">
+                <a:solidFill>
+                  <a:srgbClr val="323232"/>
+                </a:solidFill>
+              </a:defRPr>
+            </a:pPr>
+            <a:r>
+              <a:t>AI that WORKS, not just assists.</a:t>
+            </a:r>
+            <a:br/>
+            <a:r>
+              <a:t>Autonomous task execution:</a:t>
+            </a:r>
+            <a:br/>
+            <a:r>
+              <a:t>schedule, draft, assign, follow up</a:t>
+            </a:r>
+          </a:p>
+        </p:txBody>
+      </p:sp>
+      <p:sp>
+        <p:nvSpPr>
+          <p:cNvPr id="5" name="Rounded Rectangle 4"/>
+          <p:cNvSpPr/>
+          <p:nvPr/>
+        </p:nvSpPr>
+        <p:spPr>
+          <a:xfrm>
+            <a:off x="3291840" y="1463040"/>
+            <a:ext cx="2560320" cy="4114800"/>
+          </a:xfrm>
+          <a:prstGeom prst="roundRect">
+            <a:avLst/>
+          </a:prstGeom>
+          <a:solidFill>
+            <a:srgbClr val="F5FFF5"/>
+          </a:solidFill>
+          <a:ln w="25400">
+            <a:solidFill>
+              <a:srgbClr val="004FA9"/>
+            </a:solidFill>
+          </a:ln>
+        </p:spPr>
+        <p:style>
+          <a:lnRef idx="1">
+            <a:schemeClr val="accent1"/>
+          </a:lnRef>
+          <a:fillRef idx="3">
+            <a:schemeClr val="accent1"/>
+          </a:fillRef>
+          <a:effectRef idx="2">
+            <a:schemeClr val="accent1"/>
+          </a:effectRef>
+          <a:fontRef idx="minor">
+            <a:schemeClr val="lt1"/>
+          </a:fontRef>
+        </p:style>
+        <p:txBody>
+          <a:bodyPr rtlCol="0" anchor="ctr" wrap="square" lIns="137160" rIns="137160"/>
+          <a:lstStyle/>
+          <a:p>
+            <a:pPr algn="ctr">
+              <a:defRPr sz="1400" b="1">
+                <a:solidFill>
+                  <a:srgbClr val="004FA9"/>
+                </a:solidFill>
+              </a:defRPr>
+            </a:pPr>
+            <a:r>
+              <a:t>Solution 2</a:t>
+            </a:r>
+          </a:p>
+          <a:p>
+            <a:pPr>
+              <a:defRPr sz="400"/>
+            </a:pPr>
+          </a:p>
+          <a:p>
+            <a:pPr algn="ctr">
+              <a:defRPr sz="1400" b="1">
+                <a:solidFill>
+                  <a:srgbClr val="002060"/>
+                </a:solidFill>
+              </a:defRPr>
+            </a:pPr>
+            <a:r>
+              <a:t>Webex AI Agent</a:t>
+            </a:r>
+            <a:br/>
+            <a:r>
+              <a:t>Platform (SDK)</a:t>
+            </a:r>
+          </a:p>
+          <a:p>
+            <a:pPr>
+              <a:defRPr sz="800"/>
+            </a:pPr>
+          </a:p>
+          <a:p>
+            <a:pPr algn="ctr">
+              <a:defRPr sz="1100">
+                <a:solidFill>
+                  <a:srgbClr val="323232"/>
+                </a:solidFill>
+              </a:defRPr>
+            </a:pPr>
+            <a:r>
+              <a:t>Open developer framework for</a:t>
+            </a:r>
+            <a:br/>
+            <a:r>
+              <a:t>vertical-specific AI agents.</a:t>
+            </a:r>
+            <a:br/>
+            <a:r>
+              <a:t>Agent marketplace ecosystem</a:t>
+            </a:r>
+          </a:p>
+        </p:txBody>
+      </p:sp>
+      <p:sp>
+        <p:nvSpPr>
+          <p:cNvPr id="6" name="Rounded Rectangle 5"/>
+          <p:cNvSpPr/>
+          <p:nvPr/>
+        </p:nvSpPr>
+        <p:spPr>
+          <a:xfrm>
+            <a:off x="6126480" y="1463040"/>
+            <a:ext cx="2560320" cy="4114800"/>
+          </a:xfrm>
+          <a:prstGeom prst="roundRect">
+            <a:avLst/>
+          </a:prstGeom>
+          <a:solidFill>
+            <a:srgbClr val="F5FFF5"/>
+          </a:solidFill>
+          <a:ln w="25400">
+            <a:solidFill>
+              <a:srgbClr val="F39C12"/>
+            </a:solidFill>
+          </a:ln>
+        </p:spPr>
+        <p:style>
+          <a:lnRef idx="1">
+            <a:schemeClr val="accent1"/>
+          </a:lnRef>
+          <a:fillRef idx="3">
+            <a:schemeClr val="accent1"/>
+          </a:fillRef>
+          <a:effectRef idx="2">
+            <a:schemeClr val="accent1"/>
+          </a:effectRef>
+          <a:fontRef idx="minor">
+            <a:schemeClr val="lt1"/>
+          </a:fontRef>
+        </p:style>
+        <p:txBody>
+          <a:bodyPr rtlCol="0" anchor="ctr" wrap="square" lIns="137160" rIns="137160"/>
+          <a:lstStyle/>
+          <a:p>
+            <a:pPr algn="ctr">
+              <a:defRPr sz="1400" b="1">
+                <a:solidFill>
+                  <a:srgbClr val="F39C12"/>
+                </a:solidFill>
+              </a:defRPr>
+            </a:pPr>
+            <a:r>
+              <a:t>Solution 3</a:t>
+            </a:r>
+          </a:p>
+          <a:p>
+            <a:pPr>
+              <a:defRPr sz="400"/>
+            </a:pPr>
+          </a:p>
+          <a:p>
+            <a:pPr algn="ctr">
+              <a:defRPr sz="1400" b="1">
+                <a:solidFill>
+                  <a:srgbClr val="002060"/>
+                </a:solidFill>
+              </a:defRPr>
+            </a:pPr>
+            <a:r>
+              <a:t>Intelligent Workflow</a:t>
+            </a:r>
+            <a:br/>
+            <a:r>
+              <a:t>Engine</a:t>
+            </a:r>
+          </a:p>
+          <a:p>
+            <a:pPr>
+              <a:defRPr sz="800"/>
+            </a:pPr>
+          </a:p>
+          <a:p>
+            <a:pPr algn="ctr">
+              <a:defRPr sz="1100">
+                <a:solidFill>
+                  <a:srgbClr val="323232"/>
+                </a:solidFill>
+              </a:defRPr>
+            </a:pPr>
+            <a:r>
+              <a:t>200+ enterprise integrations.</a:t>
+            </a:r>
+            <a:br/>
+            <a:r>
+              <a:t>AI-powered cross-platform</a:t>
+            </a:r>
+            <a:br/>
+            <a:r>
+              <a:t>workflow automation</a:t>
+            </a:r>
+          </a:p>
+        </p:txBody>
+      </p:sp>
+      <p:sp>
+        <p:nvSpPr>
+          <p:cNvPr id="7" name="TextBox 6"/>
           <p:cNvSpPr txBox="1"/>
           <p:nvPr/>
         </p:nvSpPr>
@@ -4225,7 +4191,7 @@
               </a:defRPr>
             </a:pPr>
             <a:r>
-              <a:t>Solution 1: Technical Architecture</a:t>
+              <a:t>Solution 1: Agentic AI Transformation</a:t>
             </a:r>
           </a:p>
           <a:p>
@@ -4237,7 +4203,7 @@
               </a:defRPr>
             </a:pPr>
             <a:r>
-              <a:t>How Agentic AI Works in Webex</a:t>
+              <a:t>Evolving from Assistant to Autonomous Agent</a:t>
             </a:r>
           </a:p>
         </p:txBody>
@@ -4285,460 +4251,33 @@
           </a:p>
         </p:txBody>
       </p:sp>
-      <p:sp>
-        <p:nvSpPr>
-          <p:cNvPr id="4" name="TextBox 3"/>
-          <p:cNvSpPr txBox="1"/>
+      <p:pic>
+        <p:nvPicPr>
+          <p:cNvPr id="4" name="Picture 3" descr="agentic_evolution.png"/>
+          <p:cNvPicPr>
+            <a:picLocks noChangeAspect="1"/>
+          </p:cNvPicPr>
           <p:nvPr/>
-        </p:nvSpPr>
-        <p:spPr>
-          <a:xfrm>
-            <a:off x="457200" y="1371600"/>
-            <a:ext cx="3931920" cy="5029200"/>
+        </p:nvPicPr>
+        <p:blipFill>
+          <a:blip r:embed="rId2"/>
+          <a:stretch>
+            <a:fillRect/>
+          </a:stretch>
+        </p:blipFill>
+        <p:spPr>
+          <a:xfrm>
+            <a:off x="274320" y="1280160"/>
+            <a:ext cx="8595360" cy="5029200"/>
           </a:xfrm>
           <a:prstGeom prst="rect">
             <a:avLst/>
           </a:prstGeom>
-          <a:noFill/>
-        </p:spPr>
-        <p:txBody>
-          <a:bodyPr wrap="square">
-            <a:spAutoFit/>
-          </a:bodyPr>
-          <a:lstStyle/>
-          <a:p>
-            <a:pPr>
-              <a:defRPr sz="1400" b="1">
-                <a:solidFill>
-                  <a:srgbClr val="002060"/>
-                </a:solidFill>
-              </a:defRPr>
-            </a:pPr>
-            <a:r>
-              <a:t>Core Components:</a:t>
-            </a:r>
-          </a:p>
-          <a:p>
-            <a:pPr>
-              <a:defRPr sz="600"/>
-            </a:pPr>
-          </a:p>
-          <a:p>
-            <a:pPr>
-              <a:defRPr sz="1100">
-                <a:solidFill>
-                  <a:srgbClr val="323232"/>
-                </a:solidFill>
-              </a:defRPr>
-            </a:pPr>
-            <a:r>
-              <a:t>1. Task Decomposition Engine</a:t>
-            </a:r>
-          </a:p>
-          <a:p>
-            <a:pPr>
-              <a:defRPr sz="1100">
-                <a:solidFill>
-                  <a:srgbClr val="323232"/>
-                </a:solidFill>
-              </a:defRPr>
-            </a:pPr>
-            <a:r>
-              <a:t>   LLM breaks requests into sub-tasks</a:t>
-            </a:r>
-          </a:p>
-          <a:p>
-            <a:pPr>
-              <a:defRPr sz="1100">
-                <a:solidFill>
-                  <a:srgbClr val="323232"/>
-                </a:solidFill>
-              </a:defRPr>
-            </a:pPr>
-            <a:r>
-              <a:t>   e.g., 'organize review' becomes:</a:t>
-            </a:r>
-          </a:p>
-          <a:p>
-            <a:pPr>
-              <a:defRPr sz="1100">
-                <a:solidFill>
-                  <a:srgbClr val="323232"/>
-                </a:solidFill>
-              </a:defRPr>
-            </a:pPr>
-            <a:r>
-              <a:t>   schedule + invite + agenda + data</a:t>
-            </a:r>
-          </a:p>
-          <a:p>
-            <a:pPr>
-              <a:defRPr sz="600"/>
-            </a:pPr>
-          </a:p>
-          <a:p>
-            <a:pPr>
-              <a:defRPr sz="1100">
-                <a:solidFill>
-                  <a:srgbClr val="323232"/>
-                </a:solidFill>
-              </a:defRPr>
-            </a:pPr>
-            <a:r>
-              <a:t>2. Execution Layer</a:t>
-            </a:r>
-          </a:p>
-          <a:p>
-            <a:pPr>
-              <a:defRPr sz="1100">
-                <a:solidFill>
-                  <a:srgbClr val="323232"/>
-                </a:solidFill>
-              </a:defRPr>
-            </a:pPr>
-            <a:r>
-              <a:t>   Secure API connectors to Salesforce,</a:t>
-            </a:r>
-          </a:p>
-          <a:p>
-            <a:pPr>
-              <a:defRPr sz="1100">
-                <a:solidFill>
-                  <a:srgbClr val="323232"/>
-                </a:solidFill>
-              </a:defRPr>
-            </a:pPr>
-            <a:r>
-              <a:t>   Jira, ServiceNow, SAP, etc.</a:t>
-            </a:r>
-          </a:p>
-          <a:p>
-            <a:pPr>
-              <a:defRPr sz="600"/>
-            </a:pPr>
-          </a:p>
-          <a:p>
-            <a:pPr>
-              <a:defRPr sz="1100">
-                <a:solidFill>
-                  <a:srgbClr val="323232"/>
-                </a:solidFill>
-              </a:defRPr>
-            </a:pPr>
-            <a:r>
-              <a:t>3. Human-in-the-Loop Guardrails</a:t>
-            </a:r>
-          </a:p>
-          <a:p>
-            <a:pPr>
-              <a:defRPr sz="1100">
-                <a:solidFill>
-                  <a:srgbClr val="323232"/>
-                </a:solidFill>
-              </a:defRPr>
-            </a:pPr>
-            <a:r>
-              <a:t>   Configurable approval levels</a:t>
-            </a:r>
-          </a:p>
-          <a:p>
-            <a:pPr>
-              <a:defRPr sz="1100">
-                <a:solidFill>
-                  <a:srgbClr val="323232"/>
-                </a:solidFill>
-              </a:defRPr>
-            </a:pPr>
-            <a:r>
-              <a:t>   High-stakes = user confirms</a:t>
-            </a:r>
-          </a:p>
-          <a:p>
-            <a:pPr>
-              <a:defRPr sz="1100">
-                <a:solidFill>
-                  <a:srgbClr val="323232"/>
-                </a:solidFill>
-              </a:defRPr>
-            </a:pPr>
-            <a:r>
-              <a:t>   Routine = auto-execute</a:t>
-            </a:r>
-          </a:p>
-          <a:p>
-            <a:pPr>
-              <a:defRPr sz="600"/>
-            </a:pPr>
-          </a:p>
-          <a:p>
-            <a:pPr>
-              <a:defRPr sz="1100">
-                <a:solidFill>
-                  <a:srgbClr val="323232"/>
-                </a:solidFill>
-              </a:defRPr>
-            </a:pPr>
-            <a:r>
-              <a:t>4. Learning Loop</a:t>
-            </a:r>
-          </a:p>
-          <a:p>
-            <a:pPr>
-              <a:defRPr sz="1100">
-                <a:solidFill>
-                  <a:srgbClr val="323232"/>
-                </a:solidFill>
-              </a:defRPr>
-            </a:pPr>
-            <a:r>
-              <a:t>   Reinforcement from user feedback</a:t>
-            </a:r>
-          </a:p>
-          <a:p>
-            <a:pPr>
-              <a:defRPr sz="1100">
-                <a:solidFill>
-                  <a:srgbClr val="323232"/>
-                </a:solidFill>
-              </a:defRPr>
-            </a:pPr>
-            <a:r>
-              <a:t>   Splunk data for pattern recognition</a:t>
-            </a:r>
-          </a:p>
-        </p:txBody>
-      </p:sp>
+        </p:spPr>
+      </p:pic>
       <p:sp>
         <p:nvSpPr>
           <p:cNvPr id="5" name="TextBox 4"/>
-          <p:cNvSpPr txBox="1"/>
-          <p:nvPr/>
-        </p:nvSpPr>
-        <p:spPr>
-          <a:xfrm>
-            <a:off x="4572000" y="1371600"/>
-            <a:ext cx="4114800" cy="5029200"/>
-          </a:xfrm>
-          <a:prstGeom prst="rect">
-            <a:avLst/>
-          </a:prstGeom>
-          <a:noFill/>
-        </p:spPr>
-        <p:txBody>
-          <a:bodyPr wrap="square">
-            <a:spAutoFit/>
-          </a:bodyPr>
-          <a:lstStyle/>
-          <a:p>
-            <a:pPr>
-              <a:defRPr sz="1400" b="1">
-                <a:solidFill>
-                  <a:srgbClr val="27AE60"/>
-                </a:solidFill>
-              </a:defRPr>
-            </a:pPr>
-            <a:r>
-              <a:t>Feasibility Evidence:</a:t>
-            </a:r>
-          </a:p>
-          <a:p>
-            <a:pPr>
-              <a:defRPr sz="600"/>
-            </a:pPr>
-          </a:p>
-          <a:p>
-            <a:pPr>
-              <a:defRPr sz="1100">
-                <a:solidFill>
-                  <a:srgbClr val="323232"/>
-                </a:solidFill>
-              </a:defRPr>
-            </a:pPr>
-            <a:r>
-              <a:t>R&amp;D Budget: $7.98B (FY2024)</a:t>
-            </a:r>
-          </a:p>
-          <a:p>
-            <a:pPr>
-              <a:defRPr sz="1100">
-                <a:solidFill>
-                  <a:srgbClr val="323232"/>
-                </a:solidFill>
-              </a:defRPr>
-            </a:pPr>
-            <a:r>
-              <a:t>  Sufficient for agentic development</a:t>
-            </a:r>
-          </a:p>
-          <a:p>
-            <a:pPr>
-              <a:defRPr sz="600"/>
-            </a:pPr>
-          </a:p>
-          <a:p>
-            <a:pPr>
-              <a:defRPr sz="1100">
-                <a:solidFill>
-                  <a:srgbClr val="323232"/>
-                </a:solidFill>
-              </a:defRPr>
-            </a:pPr>
-            <a:r>
-              <a:t>Existing AI Infrastructure:</a:t>
-            </a:r>
-          </a:p>
-          <a:p>
-            <a:pPr>
-              <a:defRPr sz="1100">
-                <a:solidFill>
-                  <a:srgbClr val="323232"/>
-                </a:solidFill>
-              </a:defRPr>
-            </a:pPr>
-            <a:r>
-              <a:t>  150M+ users already served</a:t>
-            </a:r>
-          </a:p>
-          <a:p>
-            <a:pPr>
-              <a:defRPr sz="1100">
-                <a:solidFill>
-                  <a:srgbClr val="323232"/>
-                </a:solidFill>
-              </a:defRPr>
-            </a:pPr>
-            <a:r>
-              <a:t>  Real-time transcription at scale</a:t>
-            </a:r>
-          </a:p>
-          <a:p>
-            <a:pPr>
-              <a:defRPr sz="600"/>
-            </a:pPr>
-          </a:p>
-          <a:p>
-            <a:pPr>
-              <a:defRPr sz="1100">
-                <a:solidFill>
-                  <a:srgbClr val="323232"/>
-                </a:solidFill>
-              </a:defRPr>
-            </a:pPr>
-            <a:r>
-              <a:t>Splunk Acquisition ($28B):</a:t>
-            </a:r>
-          </a:p>
-          <a:p>
-            <a:pPr>
-              <a:defRPr sz="1100">
-                <a:solidFill>
-                  <a:srgbClr val="323232"/>
-                </a:solidFill>
-              </a:defRPr>
-            </a:pPr>
-            <a:r>
-              <a:t>  Enterprise data observability</a:t>
-            </a:r>
-          </a:p>
-          <a:p>
-            <a:pPr>
-              <a:defRPr sz="1100">
-                <a:solidFill>
-                  <a:srgbClr val="323232"/>
-                </a:solidFill>
-              </a:defRPr>
-            </a:pPr>
-            <a:r>
-              <a:t>  Pattern recognition capability</a:t>
-            </a:r>
-          </a:p>
-          <a:p>
-            <a:pPr>
-              <a:defRPr sz="600"/>
-            </a:pPr>
-          </a:p>
-          <a:p>
-            <a:pPr>
-              <a:defRPr sz="1100">
-                <a:solidFill>
-                  <a:srgbClr val="323232"/>
-                </a:solidFill>
-              </a:defRPr>
-            </a:pPr>
-            <a:r>
-              <a:t>Security Advantage:</a:t>
-            </a:r>
-          </a:p>
-          <a:p>
-            <a:pPr>
-              <a:defRPr sz="1100">
-                <a:solidFill>
-                  <a:srgbClr val="323232"/>
-                </a:solidFill>
-              </a:defRPr>
-            </a:pPr>
-            <a:r>
-              <a:t>  FedRAMP, HIPAA, SOC 2 Type II</a:t>
-            </a:r>
-          </a:p>
-          <a:p>
-            <a:pPr>
-              <a:defRPr sz="1100">
-                <a:solidFill>
-                  <a:srgbClr val="323232"/>
-                </a:solidFill>
-              </a:defRPr>
-            </a:pPr>
-            <a:r>
-              <a:t>  Zero-trust agent architecture</a:t>
-            </a:r>
-          </a:p>
-          <a:p>
-            <a:pPr>
-              <a:defRPr sz="600"/>
-            </a:pPr>
-          </a:p>
-          <a:p>
-            <a:pPr>
-              <a:defRPr sz="1100" b="1">
-                <a:solidFill>
-                  <a:srgbClr val="004FA9"/>
-                </a:solidFill>
-              </a:defRPr>
-            </a:pPr>
-            <a:r>
-              <a:t>Scalability: Microservices-based</a:t>
-            </a:r>
-          </a:p>
-          <a:p>
-            <a:pPr>
-              <a:defRPr sz="1100" b="1">
-                <a:solidFill>
-                  <a:srgbClr val="004FA9"/>
-                </a:solidFill>
-              </a:defRPr>
-            </a:pPr>
-            <a:r>
-              <a:t>agents on Cisco global cloud (40+</a:t>
-            </a:r>
-          </a:p>
-          <a:p>
-            <a:pPr>
-              <a:defRPr sz="1100" b="1">
-                <a:solidFill>
-                  <a:srgbClr val="004FA9"/>
-                </a:solidFill>
-              </a:defRPr>
-            </a:pPr>
-            <a:r>
-              <a:t>data center locations)</a:t>
-            </a:r>
-          </a:p>
-        </p:txBody>
-      </p:sp>
-      <p:sp>
-        <p:nvSpPr>
-          <p:cNvPr id="6" name="TextBox 5"/>
           <p:cNvSpPr txBox="1"/>
           <p:nvPr/>
         </p:nvSpPr>
@@ -4844,7 +4383,7 @@
               </a:defRPr>
             </a:pPr>
             <a:r>
-              <a:t>Solution 2: Webex AI Agent Platform</a:t>
+              <a:t>Solution 1: Technical Architecture</a:t>
             </a:r>
           </a:p>
           <a:p>
@@ -4856,7 +4395,7 @@
               </a:defRPr>
             </a:pPr>
             <a:r>
-              <a:t>Open Developer SDK &amp; Agent Marketplace</a:t>
+              <a:t>How Agentic AI Works in Webex</a:t>
             </a:r>
           </a:p>
         </p:txBody>
@@ -4934,7 +4473,7 @@
               </a:defRPr>
             </a:pPr>
             <a:r>
-              <a:t>Platform Components:</a:t>
+              <a:t>Perceive-Reason-Act Architecture:</a:t>
             </a:r>
           </a:p>
           <a:p>
@@ -4951,7 +4490,7 @@
               </a:defRPr>
             </a:pPr>
             <a:r>
-              <a:t>1. Agent SDK</a:t>
+              <a:t>1. PERCEIVE: Webex AI Codec</a:t>
             </a:r>
           </a:p>
           <a:p>
@@ -4963,7 +4502,7 @@
               </a:defRPr>
             </a:pPr>
             <a:r>
-              <a:t>   Python &amp; JavaScript SDKs</a:t>
+              <a:t>   Real-Time Media Models (RMM)</a:t>
             </a:r>
           </a:p>
           <a:p>
@@ -4975,8 +4514,13 @@
               </a:defRPr>
             </a:pPr>
             <a:r>
-              <a:t>   Pre-built agent templates</a:t>
-            </a:r>
+              <a:t>   process audio + detect task intents</a:t>
+            </a:r>
+          </a:p>
+          <a:p>
+            <a:pPr>
+              <a:defRPr sz="600"/>
+            </a:pPr>
           </a:p>
           <a:p>
             <a:pPr>
@@ -4987,7 +4531,43 @@
               </a:defRPr>
             </a:pPr>
             <a:r>
-              <a:t>   (meeting coordinator, PM, etc.)</a:t>
+              <a:t>2. REASON: NLP Task Decomposition</a:t>
+            </a:r>
+          </a:p>
+          <a:p>
+            <a:pPr>
+              <a:defRPr sz="1100">
+                <a:solidFill>
+                  <a:srgbClr val="323232"/>
+                </a:solidFill>
+              </a:defRPr>
+            </a:pPr>
+            <a:r>
+              <a:t>   LLM identifies intent, fetches context</a:t>
+            </a:r>
+          </a:p>
+          <a:p>
+            <a:pPr>
+              <a:defRPr sz="1100">
+                <a:solidFill>
+                  <a:srgbClr val="323232"/>
+                </a:solidFill>
+              </a:defRPr>
+            </a:pPr>
+            <a:r>
+              <a:t>   via A2A (Agent-to-Agent) Protocols</a:t>
+            </a:r>
+          </a:p>
+          <a:p>
+            <a:pPr>
+              <a:defRPr sz="1100">
+                <a:solidFill>
+                  <a:srgbClr val="323232"/>
+                </a:solidFill>
+              </a:defRPr>
+            </a:pPr>
+            <a:r>
+              <a:t>   from Jira, Salesforce, SAP, etc.</a:t>
             </a:r>
           </a:p>
           <a:p>
@@ -5004,7 +4584,7 @@
               </a:defRPr>
             </a:pPr>
             <a:r>
-              <a:t>2. Agent Runtime</a:t>
+              <a:t>3. ACT: Autonomous Execution</a:t>
             </a:r>
           </a:p>
           <a:p>
@@ -5016,7 +4596,7 @@
               </a:defRPr>
             </a:pPr>
             <a:r>
-              <a:t>   Sandboxed execution in Webex Cloud</a:t>
+              <a:t>   Agent pushes via secure API</a:t>
             </a:r>
           </a:p>
           <a:p>
@@ -5028,7 +4608,7 @@
               </a:defRPr>
             </a:pPr>
             <a:r>
-              <a:t>   Enterprise-grade security &amp; isolation</a:t>
+              <a:t>   Human-in-the-loop: Approve/Reject</a:t>
             </a:r>
           </a:p>
           <a:p>
@@ -5040,7 +4620,7 @@
               </a:defRPr>
             </a:pPr>
             <a:r>
-              <a:t>   Container-based (Kubernetes)</a:t>
+              <a:t>   Confirmation posted to Webex chat</a:t>
             </a:r>
           </a:p>
           <a:p>
@@ -5057,7 +4637,7 @@
               </a:defRPr>
             </a:pPr>
             <a:r>
-              <a:t>3. Agent Marketplace</a:t>
+              <a:t>4. OBSERVE: Splunk Observability</a:t>
             </a:r>
           </a:p>
           <a:p>
@@ -5069,7 +4649,7 @@
               </a:defRPr>
             </a:pPr>
             <a:r>
-              <a:t>   Discover, deploy, monetize agents</a:t>
+              <a:t>   End-to-end monitoring + learning loop</a:t>
             </a:r>
           </a:p>
           <a:p>
@@ -5081,60 +4661,7 @@
               </a:defRPr>
             </a:pPr>
             <a:r>
-              <a:t>   Revenue sharing for developers</a:t>
-            </a:r>
-          </a:p>
-          <a:p>
-            <a:pPr>
-              <a:defRPr sz="600"/>
-            </a:pPr>
-          </a:p>
-          <a:p>
-            <a:pPr>
-              <a:defRPr sz="1100">
-                <a:solidFill>
-                  <a:srgbClr val="323232"/>
-                </a:solidFill>
-              </a:defRPr>
-            </a:pPr>
-            <a:r>
-              <a:t>4. Vertical Templates</a:t>
-            </a:r>
-          </a:p>
-          <a:p>
-            <a:pPr>
-              <a:defRPr sz="1100">
-                <a:solidFill>
-                  <a:srgbClr val="323232"/>
-                </a:solidFill>
-              </a:defRPr>
-            </a:pPr>
-            <a:r>
-              <a:t>   Healthcare (HIPAA-compliant)</a:t>
-            </a:r>
-          </a:p>
-          <a:p>
-            <a:pPr>
-              <a:defRPr sz="1100">
-                <a:solidFill>
-                  <a:srgbClr val="323232"/>
-                </a:solidFill>
-              </a:defRPr>
-            </a:pPr>
-            <a:r>
-              <a:t>   Finance (compliance-aware)</a:t>
-            </a:r>
-          </a:p>
-          <a:p>
-            <a:pPr>
-              <a:defRPr sz="1100">
-                <a:solidFill>
-                  <a:srgbClr val="323232"/>
-                </a:solidFill>
-              </a:defRPr>
-            </a:pPr>
-            <a:r>
-              <a:t>   Government (FedRAMP-certified)</a:t>
+              <a:t>   Reinforcement from user feedback</a:t>
             </a:r>
           </a:p>
         </p:txBody>
@@ -5164,198 +4691,205 @@
             <a:pPr>
               <a:defRPr sz="1400" b="1">
                 <a:solidFill>
+                  <a:srgbClr val="27AE60"/>
+                </a:solidFill>
+              </a:defRPr>
+            </a:pPr>
+            <a:r>
+              <a:t>Feasibility Evidence:</a:t>
+            </a:r>
+          </a:p>
+          <a:p>
+            <a:pPr>
+              <a:defRPr sz="600"/>
+            </a:pPr>
+          </a:p>
+          <a:p>
+            <a:pPr>
+              <a:defRPr sz="1100">
+                <a:solidFill>
+                  <a:srgbClr val="323232"/>
+                </a:solidFill>
+              </a:defRPr>
+            </a:pPr>
+            <a:r>
+              <a:t>R&amp;D Budget: $7.98B (FY2024)</a:t>
+            </a:r>
+          </a:p>
+          <a:p>
+            <a:pPr>
+              <a:defRPr sz="1100">
+                <a:solidFill>
+                  <a:srgbClr val="323232"/>
+                </a:solidFill>
+              </a:defRPr>
+            </a:pPr>
+            <a:r>
+              <a:t>  Sufficient for agentic development</a:t>
+            </a:r>
+          </a:p>
+          <a:p>
+            <a:pPr>
+              <a:defRPr sz="600"/>
+            </a:pPr>
+          </a:p>
+          <a:p>
+            <a:pPr>
+              <a:defRPr sz="1100">
+                <a:solidFill>
+                  <a:srgbClr val="323232"/>
+                </a:solidFill>
+              </a:defRPr>
+            </a:pPr>
+            <a:r>
+              <a:t>Existing AI Infrastructure:</a:t>
+            </a:r>
+          </a:p>
+          <a:p>
+            <a:pPr>
+              <a:defRPr sz="1100">
+                <a:solidFill>
+                  <a:srgbClr val="323232"/>
+                </a:solidFill>
+              </a:defRPr>
+            </a:pPr>
+            <a:r>
+              <a:t>  150M+ users already served</a:t>
+            </a:r>
+          </a:p>
+          <a:p>
+            <a:pPr>
+              <a:defRPr sz="1100">
+                <a:solidFill>
+                  <a:srgbClr val="323232"/>
+                </a:solidFill>
+              </a:defRPr>
+            </a:pPr>
+            <a:r>
+              <a:t>  Real-time transcription at scale</a:t>
+            </a:r>
+          </a:p>
+          <a:p>
+            <a:pPr>
+              <a:defRPr sz="600"/>
+            </a:pPr>
+          </a:p>
+          <a:p>
+            <a:pPr>
+              <a:defRPr sz="1100">
+                <a:solidFill>
+                  <a:srgbClr val="323232"/>
+                </a:solidFill>
+              </a:defRPr>
+            </a:pPr>
+            <a:r>
+              <a:t>Splunk Acquisition ($28B):</a:t>
+            </a:r>
+          </a:p>
+          <a:p>
+            <a:pPr>
+              <a:defRPr sz="1100">
+                <a:solidFill>
+                  <a:srgbClr val="323232"/>
+                </a:solidFill>
+              </a:defRPr>
+            </a:pPr>
+            <a:r>
+              <a:t>  Enterprise data observability</a:t>
+            </a:r>
+          </a:p>
+          <a:p>
+            <a:pPr>
+              <a:defRPr sz="1100">
+                <a:solidFill>
+                  <a:srgbClr val="323232"/>
+                </a:solidFill>
+              </a:defRPr>
+            </a:pPr>
+            <a:r>
+              <a:t>  Pattern recognition capability</a:t>
+            </a:r>
+          </a:p>
+          <a:p>
+            <a:pPr>
+              <a:defRPr sz="600"/>
+            </a:pPr>
+          </a:p>
+          <a:p>
+            <a:pPr>
+              <a:defRPr sz="1100">
+                <a:solidFill>
+                  <a:srgbClr val="323232"/>
+                </a:solidFill>
+              </a:defRPr>
+            </a:pPr>
+            <a:r>
+              <a:t>Security Advantage:</a:t>
+            </a:r>
+          </a:p>
+          <a:p>
+            <a:pPr>
+              <a:defRPr sz="1100">
+                <a:solidFill>
+                  <a:srgbClr val="323232"/>
+                </a:solidFill>
+              </a:defRPr>
+            </a:pPr>
+            <a:r>
+              <a:t>  FedRAMP, HIPAA, SOC 2 Type II</a:t>
+            </a:r>
+          </a:p>
+          <a:p>
+            <a:pPr>
+              <a:defRPr sz="1100">
+                <a:solidFill>
+                  <a:srgbClr val="323232"/>
+                </a:solidFill>
+              </a:defRPr>
+            </a:pPr>
+            <a:r>
+              <a:t>  Zero-trust agent architecture</a:t>
+            </a:r>
+          </a:p>
+          <a:p>
+            <a:pPr>
+              <a:defRPr sz="600"/>
+            </a:pPr>
+          </a:p>
+          <a:p>
+            <a:pPr>
+              <a:defRPr sz="1100" b="1">
+                <a:solidFill>
                   <a:srgbClr val="004FA9"/>
                 </a:solidFill>
               </a:defRPr>
             </a:pPr>
             <a:r>
-              <a:t>Adoption Strategy:</a:t>
-            </a:r>
-          </a:p>
-          <a:p>
-            <a:pPr>
-              <a:defRPr sz="600"/>
-            </a:pPr>
-          </a:p>
-          <a:p>
-            <a:pPr>
-              <a:defRPr sz="1100">
-                <a:solidFill>
-                  <a:srgbClr val="323232"/>
-                </a:solidFill>
-              </a:defRPr>
-            </a:pPr>
-            <a:r>
-              <a:t>$10M Developer Incentive Fund</a:t>
-            </a:r>
-          </a:p>
-          <a:p>
-            <a:pPr>
-              <a:defRPr sz="1100">
-                <a:solidFill>
-                  <a:srgbClr val="323232"/>
-                </a:solidFill>
-              </a:defRPr>
-            </a:pPr>
-            <a:r>
-              <a:t>  (Modeled on Salesforce Trailhead)</a:t>
-            </a:r>
-          </a:p>
-          <a:p>
-            <a:pPr>
-              <a:defRPr sz="600"/>
-            </a:pPr>
-          </a:p>
-          <a:p>
-            <a:pPr>
-              <a:defRPr sz="1100">
-                <a:solidFill>
-                  <a:srgbClr val="323232"/>
-                </a:solidFill>
-              </a:defRPr>
-            </a:pPr>
-            <a:r>
-              <a:t>University Hackathons (50+)</a:t>
-            </a:r>
-          </a:p>
-          <a:p>
-            <a:pPr>
-              <a:defRPr sz="1100">
-                <a:solidFill>
-                  <a:srgbClr val="323232"/>
-                </a:solidFill>
-              </a:defRPr>
-            </a:pPr>
-            <a:r>
-              <a:t>  Partner with CS programs</a:t>
-            </a:r>
-          </a:p>
-          <a:p>
-            <a:pPr>
-              <a:defRPr sz="600"/>
-            </a:pPr>
-          </a:p>
-          <a:p>
-            <a:pPr>
-              <a:defRPr sz="1100">
-                <a:solidFill>
-                  <a:srgbClr val="323232"/>
-                </a:solidFill>
-              </a:defRPr>
-            </a:pPr>
-            <a:r>
-              <a:t>Systems Integrator Partners</a:t>
-            </a:r>
-          </a:p>
-          <a:p>
-            <a:pPr>
-              <a:defRPr sz="1100">
-                <a:solidFill>
-                  <a:srgbClr val="323232"/>
-                </a:solidFill>
-              </a:defRPr>
-            </a:pPr>
-            <a:r>
-              <a:t>  Accenture, Deloitte, Wipro</a:t>
-            </a:r>
-          </a:p>
-          <a:p>
-            <a:pPr>
-              <a:defRPr sz="1100">
-                <a:solidFill>
-                  <a:srgbClr val="323232"/>
-                </a:solidFill>
-              </a:defRPr>
-            </a:pPr>
-            <a:r>
-              <a:t>  for initial vertical agents</a:t>
-            </a:r>
-          </a:p>
-          <a:p>
-            <a:pPr>
-              <a:defRPr sz="600"/>
-            </a:pPr>
-          </a:p>
-          <a:p>
-            <a:pPr>
-              <a:defRPr sz="1400" b="1">
-                <a:solidFill>
-                  <a:srgbClr val="F39C12"/>
-                </a:solidFill>
-              </a:defRPr>
-            </a:pPr>
-            <a:r>
-              <a:t>Risk Mitigation:</a:t>
-            </a:r>
-          </a:p>
-          <a:p>
-            <a:pPr>
-              <a:defRPr sz="600"/>
-            </a:pPr>
-          </a:p>
-          <a:p>
-            <a:pPr>
-              <a:defRPr sz="1100">
-                <a:solidFill>
-                  <a:srgbClr val="323232"/>
-                </a:solidFill>
-              </a:defRPr>
-            </a:pPr>
-            <a:r>
-              <a:t>Primary risk: developer adoption</a:t>
-            </a:r>
-          </a:p>
-          <a:p>
-            <a:pPr>
-              <a:defRPr sz="1100">
-                <a:solidFill>
-                  <a:srgbClr val="323232"/>
-                </a:solidFill>
-              </a:defRPr>
-            </a:pPr>
-            <a:r>
-              <a:t>  Mitigation: incentives + hackathons</a:t>
-            </a:r>
-          </a:p>
-          <a:p>
-            <a:pPr>
-              <a:defRPr sz="600"/>
-            </a:pPr>
-          </a:p>
-          <a:p>
-            <a:pPr>
-              <a:defRPr sz="1100">
-                <a:solidFill>
-                  <a:srgbClr val="323232"/>
-                </a:solidFill>
-              </a:defRPr>
-            </a:pPr>
-            <a:r>
-              <a:t>Security risk: 3rd-party agents</a:t>
-            </a:r>
-          </a:p>
-          <a:p>
-            <a:pPr>
-              <a:defRPr sz="1100">
-                <a:solidFill>
-                  <a:srgbClr val="323232"/>
-                </a:solidFill>
-              </a:defRPr>
-            </a:pPr>
-            <a:r>
-              <a:t>  Mitigation: sandboxed execution +</a:t>
-            </a:r>
-          </a:p>
-          <a:p>
-            <a:pPr>
-              <a:defRPr sz="1100">
-                <a:solidFill>
-                  <a:srgbClr val="323232"/>
-                </a:solidFill>
-              </a:defRPr>
-            </a:pPr>
-            <a:r>
-              <a:t>  mandatory security review process</a:t>
+              <a:t>Scalability: Microservices-based</a:t>
+            </a:r>
+          </a:p>
+          <a:p>
+            <a:pPr>
+              <a:defRPr sz="1100" b="1">
+                <a:solidFill>
+                  <a:srgbClr val="004FA9"/>
+                </a:solidFill>
+              </a:defRPr>
+            </a:pPr>
+            <a:r>
+              <a:t>agents on Cisco global cloud (40+</a:t>
+            </a:r>
+          </a:p>
+          <a:p>
+            <a:pPr>
+              <a:defRPr sz="1100" b="1">
+                <a:solidFill>
+                  <a:srgbClr val="004FA9"/>
+                </a:solidFill>
+              </a:defRPr>
+            </a:pPr>
+            <a:r>
+              <a:t>data center locations)</a:t>
             </a:r>
           </a:p>
         </p:txBody>
@@ -5468,7 +5002,7 @@
               </a:defRPr>
             </a:pPr>
             <a:r>
-              <a:t>Solution 3: Intelligent Workflow Engine</a:t>
+              <a:t>Solution 2: Webex AI Agent Platform</a:t>
             </a:r>
           </a:p>
           <a:p>
@@ -5480,7 +5014,7 @@
               </a:defRPr>
             </a:pPr>
             <a:r>
-              <a:t>AI-Powered Cross-Platform Automation</a:t>
+              <a:t>Open Developer SDK &amp; Agent Marketplace</a:t>
             </a:r>
           </a:p>
         </p:txBody>
@@ -5537,7 +5071,7 @@
         <p:spPr>
           <a:xfrm>
             <a:off x="457200" y="1371600"/>
-            <a:ext cx="8229600" cy="5029200"/>
+            <a:ext cx="3931920" cy="5029200"/>
           </a:xfrm>
           <a:prstGeom prst="rect">
             <a:avLst/>
@@ -5558,7 +5092,7 @@
               </a:defRPr>
             </a:pPr>
             <a:r>
-              <a:t>How It Works:</a:t>
+              <a:t>Platform Components:</a:t>
             </a:r>
           </a:p>
           <a:p>
@@ -5575,7 +5109,43 @@
               </a:defRPr>
             </a:pPr>
             <a:r>
-              <a:t>User says: 'After every customer call, update the CRM, create a follow-up task, and schedule a review if deal &gt; $50K'</a:t>
+              <a:t>1. Agent SDK</a:t>
+            </a:r>
+          </a:p>
+          <a:p>
+            <a:pPr>
+              <a:defRPr sz="1100">
+                <a:solidFill>
+                  <a:srgbClr val="323232"/>
+                </a:solidFill>
+              </a:defRPr>
+            </a:pPr>
+            <a:r>
+              <a:t>   Python &amp; JavaScript SDKs</a:t>
+            </a:r>
+          </a:p>
+          <a:p>
+            <a:pPr>
+              <a:defRPr sz="1100">
+                <a:solidFill>
+                  <a:srgbClr val="323232"/>
+                </a:solidFill>
+              </a:defRPr>
+            </a:pPr>
+            <a:r>
+              <a:t>   Pre-built agent templates</a:t>
+            </a:r>
+          </a:p>
+          <a:p>
+            <a:pPr>
+              <a:defRPr sz="1100">
+                <a:solidFill>
+                  <a:srgbClr val="323232"/>
+                </a:solidFill>
+              </a:defRPr>
+            </a:pPr>
+            <a:r>
+              <a:t>   (meeting coordinator, PM, etc.)</a:t>
             </a:r>
           </a:p>
           <a:p>
@@ -5585,14 +5155,179 @@
           </a:p>
           <a:p>
             <a:pPr>
+              <a:defRPr sz="1100">
+                <a:solidFill>
+                  <a:srgbClr val="323232"/>
+                </a:solidFill>
+              </a:defRPr>
+            </a:pPr>
+            <a:r>
+              <a:t>2. Agent Runtime</a:t>
+            </a:r>
+          </a:p>
+          <a:p>
+            <a:pPr>
+              <a:defRPr sz="1100">
+                <a:solidFill>
+                  <a:srgbClr val="323232"/>
+                </a:solidFill>
+              </a:defRPr>
+            </a:pPr>
+            <a:r>
+              <a:t>   Sandboxed execution in Webex Cloud</a:t>
+            </a:r>
+          </a:p>
+          <a:p>
+            <a:pPr>
+              <a:defRPr sz="1100">
+                <a:solidFill>
+                  <a:srgbClr val="323232"/>
+                </a:solidFill>
+              </a:defRPr>
+            </a:pPr>
+            <a:r>
+              <a:t>   Enterprise-grade security &amp; isolation</a:t>
+            </a:r>
+          </a:p>
+          <a:p>
+            <a:pPr>
+              <a:defRPr sz="1100">
+                <a:solidFill>
+                  <a:srgbClr val="323232"/>
+                </a:solidFill>
+              </a:defRPr>
+            </a:pPr>
+            <a:r>
+              <a:t>   Container-based (Kubernetes)</a:t>
+            </a:r>
+          </a:p>
+          <a:p>
+            <a:pPr>
+              <a:defRPr sz="600"/>
+            </a:pPr>
+          </a:p>
+          <a:p>
+            <a:pPr>
+              <a:defRPr sz="1100">
+                <a:solidFill>
+                  <a:srgbClr val="323232"/>
+                </a:solidFill>
+              </a:defRPr>
+            </a:pPr>
+            <a:r>
+              <a:t>3. Agent Marketplace</a:t>
+            </a:r>
+          </a:p>
+          <a:p>
+            <a:pPr>
+              <a:defRPr sz="1100">
+                <a:solidFill>
+                  <a:srgbClr val="323232"/>
+                </a:solidFill>
+              </a:defRPr>
+            </a:pPr>
+            <a:r>
+              <a:t>   Discover, deploy, monetize agents</a:t>
+            </a:r>
+          </a:p>
+          <a:p>
+            <a:pPr>
+              <a:defRPr sz="1100">
+                <a:solidFill>
+                  <a:srgbClr val="323232"/>
+                </a:solidFill>
+              </a:defRPr>
+            </a:pPr>
+            <a:r>
+              <a:t>   Revenue sharing for developers</a:t>
+            </a:r>
+          </a:p>
+          <a:p>
+            <a:pPr>
+              <a:defRPr sz="600"/>
+            </a:pPr>
+          </a:p>
+          <a:p>
+            <a:pPr>
+              <a:defRPr sz="1100">
+                <a:solidFill>
+                  <a:srgbClr val="323232"/>
+                </a:solidFill>
+              </a:defRPr>
+            </a:pPr>
+            <a:r>
+              <a:t>4. Vertical Templates</a:t>
+            </a:r>
+          </a:p>
+          <a:p>
+            <a:pPr>
+              <a:defRPr sz="1100">
+                <a:solidFill>
+                  <a:srgbClr val="323232"/>
+                </a:solidFill>
+              </a:defRPr>
+            </a:pPr>
+            <a:r>
+              <a:t>   Healthcare (HIPAA-compliant)</a:t>
+            </a:r>
+          </a:p>
+          <a:p>
+            <a:pPr>
+              <a:defRPr sz="1100">
+                <a:solidFill>
+                  <a:srgbClr val="323232"/>
+                </a:solidFill>
+              </a:defRPr>
+            </a:pPr>
+            <a:r>
+              <a:t>   Finance (compliance-aware)</a:t>
+            </a:r>
+          </a:p>
+          <a:p>
+            <a:pPr>
+              <a:defRPr sz="1100">
+                <a:solidFill>
+                  <a:srgbClr val="323232"/>
+                </a:solidFill>
+              </a:defRPr>
+            </a:pPr>
+            <a:r>
+              <a:t>   Government (FedRAMP-certified)</a:t>
+            </a:r>
+          </a:p>
+        </p:txBody>
+      </p:sp>
+      <p:sp>
+        <p:nvSpPr>
+          <p:cNvPr id="5" name="TextBox 4"/>
+          <p:cNvSpPr txBox="1"/>
+          <p:nvPr/>
+        </p:nvSpPr>
+        <p:spPr>
+          <a:xfrm>
+            <a:off x="4572000" y="1371600"/>
+            <a:ext cx="4114800" cy="5029200"/>
+          </a:xfrm>
+          <a:prstGeom prst="rect">
+            <a:avLst/>
+          </a:prstGeom>
+          <a:noFill/>
+        </p:spPr>
+        <p:txBody>
+          <a:bodyPr wrap="square">
+            <a:spAutoFit/>
+          </a:bodyPr>
+          <a:lstStyle/>
+          <a:p>
+            <a:pPr>
               <a:defRPr sz="1400" b="1">
                 <a:solidFill>
-                  <a:srgbClr val="002060"/>
-                </a:solidFill>
-              </a:defRPr>
-            </a:pPr>
-            <a:r>
-              <a:t>Technical Architecture:</a:t>
+                  <a:srgbClr val="004FA9"/>
+                </a:solidFill>
+              </a:defRPr>
+            </a:pPr>
+            <a:r>
+              <a:t>Adoption Strategy:</a:t>
             </a:r>
           </a:p>
           <a:p>
@@ -5609,7 +5344,7 @@
               </a:defRPr>
             </a:pPr>
             <a:r>
-              <a:t>1. Intent Recognition: NLP converts requests into workflow DAGs (Directed Acyclic Graphs)</a:t>
+              <a:t>$10M Developer Incentive Fund</a:t>
             </a:r>
           </a:p>
           <a:p>
@@ -5621,8 +5356,13 @@
               </a:defRPr>
             </a:pPr>
             <a:r>
-              <a:t>2. Connector Framework: Pre-built connectors for top 50 enterprise SaaS tools</a:t>
-            </a:r>
+              <a:t>  (Modeled on Salesforce Trailhead)</a:t>
+            </a:r>
+          </a:p>
+          <a:p>
+            <a:pPr>
+              <a:defRPr sz="600"/>
+            </a:pPr>
           </a:p>
           <a:p>
             <a:pPr>
@@ -5633,7 +5373,7 @@
               </a:defRPr>
             </a:pPr>
             <a:r>
-              <a:t>   (Salesforce, HubSpot, Jira, ServiceNow, SAP, Workday, Slack, GitHub, etc.)</a:t>
+              <a:t>University Hackathons (50+)</a:t>
             </a:r>
           </a:p>
           <a:p>
@@ -5645,8 +5385,13 @@
               </a:defRPr>
             </a:pPr>
             <a:r>
-              <a:t>3. AI Orchestration Engine: Coordinates multi-agent workflows with error recovery</a:t>
-            </a:r>
+              <a:t>  Partner with CS programs</a:t>
+            </a:r>
+          </a:p>
+          <a:p>
+            <a:pPr>
+              <a:defRPr sz="600"/>
+            </a:pPr>
           </a:p>
           <a:p>
             <a:pPr>
@@ -5657,7 +5402,31 @@
               </a:defRPr>
             </a:pPr>
             <a:r>
-              <a:t>4. Analytics Dashboard: Real-time ROI tracking powered by Splunk observability</a:t>
+              <a:t>Systems Integrator Partners</a:t>
+            </a:r>
+          </a:p>
+          <a:p>
+            <a:pPr>
+              <a:defRPr sz="1100">
+                <a:solidFill>
+                  <a:srgbClr val="323232"/>
+                </a:solidFill>
+              </a:defRPr>
+            </a:pPr>
+            <a:r>
+              <a:t>  Accenture, Deloitte, Wipro</a:t>
+            </a:r>
+          </a:p>
+          <a:p>
+            <a:pPr>
+              <a:defRPr sz="1100">
+                <a:solidFill>
+                  <a:srgbClr val="323232"/>
+                </a:solidFill>
+              </a:defRPr>
+            </a:pPr>
+            <a:r>
+              <a:t>  for initial vertical agents</a:t>
             </a:r>
           </a:p>
           <a:p>
@@ -5669,12 +5438,12 @@
             <a:pPr>
               <a:defRPr sz="1400" b="1">
                 <a:solidFill>
-                  <a:srgbClr val="27AE60"/>
-                </a:solidFill>
-              </a:defRPr>
-            </a:pPr>
-            <a:r>
-              <a:t>Feasibility:</a:t>
+                  <a:srgbClr val="F39C12"/>
+                </a:solidFill>
+              </a:defRPr>
+            </a:pPr>
+            <a:r>
+              <a:t>Risk Mitigation:</a:t>
             </a:r>
           </a:p>
           <a:p>
@@ -5691,7 +5460,7 @@
               </a:defRPr>
             </a:pPr>
             <a:r>
-              <a:t>Cisco already owns AppDynamics ($3.7B acquisition) + Splunk ($28B) for monitoring</a:t>
+              <a:t>Primary risk: developer adoption</a:t>
             </a:r>
           </a:p>
           <a:p>
@@ -5703,8 +5472,13 @@
               </a:defRPr>
             </a:pPr>
             <a:r>
-              <a:t>Standard REST/GraphQL APIs available from all major SaaS platforms</a:t>
-            </a:r>
+              <a:t>  Mitigation: incentives + hackathons</a:t>
+            </a:r>
+          </a:p>
+          <a:p>
+            <a:pPr>
+              <a:defRPr sz="600"/>
+            </a:pPr>
           </a:p>
           <a:p>
             <a:pPr>
@@ -5715,31 +5489,38 @@
               </a:defRPr>
             </a:pPr>
             <a:r>
-              <a:t>Estimated development: 12-18 months for first 50 connectors, scale to 200+</a:t>
-            </a:r>
-          </a:p>
-          <a:p>
-            <a:pPr>
-              <a:defRPr sz="600"/>
-            </a:pPr>
-          </a:p>
-          <a:p>
-            <a:pPr>
-              <a:defRPr sz="1200" b="1">
-                <a:solidFill>
-                  <a:srgbClr val="004FA9"/>
-                </a:solidFill>
-              </a:defRPr>
-            </a:pPr>
-            <a:r>
-              <a:t>SaaS Integration market: $15.6B by 2027 (MarketsandMarkets)</a:t>
-            </a:r>
-          </a:p>
-        </p:txBody>
-      </p:sp>
-      <p:sp>
-        <p:nvSpPr>
-          <p:cNvPr id="5" name="TextBox 4"/>
+              <a:t>Security risk: 3rd-party agents</a:t>
+            </a:r>
+          </a:p>
+          <a:p>
+            <a:pPr>
+              <a:defRPr sz="1100">
+                <a:solidFill>
+                  <a:srgbClr val="323232"/>
+                </a:solidFill>
+              </a:defRPr>
+            </a:pPr>
+            <a:r>
+              <a:t>  Mitigation: sandboxed execution +</a:t>
+            </a:r>
+          </a:p>
+          <a:p>
+            <a:pPr>
+              <a:defRPr sz="1100">
+                <a:solidFill>
+                  <a:srgbClr val="323232"/>
+                </a:solidFill>
+              </a:defRPr>
+            </a:pPr>
+            <a:r>
+              <a:t>  mandatory security review process</a:t>
+            </a:r>
+          </a:p>
+        </p:txBody>
+      </p:sp>
+      <p:sp>
+        <p:nvSpPr>
+          <p:cNvPr id="6" name="TextBox 5"/>
           <p:cNvSpPr txBox="1"/>
           <p:nvPr/>
         </p:nvSpPr>
@@ -5845,7 +5626,7 @@
               </a:defRPr>
             </a:pPr>
             <a:r>
-              <a:t>The Agentic AI Opportunity</a:t>
+              <a:t>Solution 3: Intelligent Workflow Engine</a:t>
             </a:r>
           </a:p>
           <a:p>
@@ -5857,7 +5638,7 @@
               </a:defRPr>
             </a:pPr>
             <a:r>
-              <a:t>Market Growing from $5.1B to $47B by 2030 (CAGR 44.8%)</a:t>
+              <a:t>AI-Powered Cross-Platform Automation</a:t>
             </a:r>
           </a:p>
         </p:txBody>
@@ -5905,30 +5686,215 @@
           </a:p>
         </p:txBody>
       </p:sp>
-      <p:pic>
-        <p:nvPicPr>
-          <p:cNvPr id="4" name="Picture 3" descr="agentic_market.png"/>
-          <p:cNvPicPr>
-            <a:picLocks noChangeAspect="1"/>
-          </p:cNvPicPr>
+      <p:sp>
+        <p:nvSpPr>
+          <p:cNvPr id="4" name="TextBox 3"/>
+          <p:cNvSpPr txBox="1"/>
           <p:nvPr/>
-        </p:nvPicPr>
-        <p:blipFill>
-          <a:blip r:embed="rId2"/>
-          <a:stretch>
-            <a:fillRect/>
-          </a:stretch>
-        </p:blipFill>
-        <p:spPr>
-          <a:xfrm>
-            <a:off x="274320" y="1280160"/>
-            <a:ext cx="8595360" cy="5029200"/>
+        </p:nvSpPr>
+        <p:spPr>
+          <a:xfrm>
+            <a:off x="457200" y="1371600"/>
+            <a:ext cx="8229600" cy="5029200"/>
           </a:xfrm>
           <a:prstGeom prst="rect">
             <a:avLst/>
           </a:prstGeom>
-        </p:spPr>
-      </p:pic>
+          <a:noFill/>
+        </p:spPr>
+        <p:txBody>
+          <a:bodyPr wrap="square">
+            <a:spAutoFit/>
+          </a:bodyPr>
+          <a:lstStyle/>
+          <a:p>
+            <a:pPr>
+              <a:defRPr sz="1400" b="1">
+                <a:solidFill>
+                  <a:srgbClr val="002060"/>
+                </a:solidFill>
+              </a:defRPr>
+            </a:pPr>
+            <a:r>
+              <a:t>How It Works:</a:t>
+            </a:r>
+          </a:p>
+          <a:p>
+            <a:pPr>
+              <a:defRPr sz="600"/>
+            </a:pPr>
+          </a:p>
+          <a:p>
+            <a:pPr>
+              <a:defRPr sz="1100">
+                <a:solidFill>
+                  <a:srgbClr val="323232"/>
+                </a:solidFill>
+              </a:defRPr>
+            </a:pPr>
+            <a:r>
+              <a:t>User says: 'After every customer call, update the CRM, create a follow-up task, and schedule a review if deal &gt; $50K'</a:t>
+            </a:r>
+          </a:p>
+          <a:p>
+            <a:pPr>
+              <a:defRPr sz="600"/>
+            </a:pPr>
+          </a:p>
+          <a:p>
+            <a:pPr>
+              <a:defRPr sz="1400" b="1">
+                <a:solidFill>
+                  <a:srgbClr val="002060"/>
+                </a:solidFill>
+              </a:defRPr>
+            </a:pPr>
+            <a:r>
+              <a:t>Technical Architecture:</a:t>
+            </a:r>
+          </a:p>
+          <a:p>
+            <a:pPr>
+              <a:defRPr sz="600"/>
+            </a:pPr>
+          </a:p>
+          <a:p>
+            <a:pPr>
+              <a:defRPr sz="1100">
+                <a:solidFill>
+                  <a:srgbClr val="323232"/>
+                </a:solidFill>
+              </a:defRPr>
+            </a:pPr>
+            <a:r>
+              <a:t>1. Intent Recognition: NLP converts requests into workflow DAGs (Directed Acyclic Graphs)</a:t>
+            </a:r>
+          </a:p>
+          <a:p>
+            <a:pPr>
+              <a:defRPr sz="1100">
+                <a:solidFill>
+                  <a:srgbClr val="323232"/>
+                </a:solidFill>
+              </a:defRPr>
+            </a:pPr>
+            <a:r>
+              <a:t>2. Connector Framework: Pre-built connectors for top 50 enterprise SaaS tools</a:t>
+            </a:r>
+          </a:p>
+          <a:p>
+            <a:pPr>
+              <a:defRPr sz="1100">
+                <a:solidFill>
+                  <a:srgbClr val="323232"/>
+                </a:solidFill>
+              </a:defRPr>
+            </a:pPr>
+            <a:r>
+              <a:t>   (Salesforce, HubSpot, Jira, ServiceNow, SAP, Workday, Slack, GitHub, etc.)</a:t>
+            </a:r>
+          </a:p>
+          <a:p>
+            <a:pPr>
+              <a:defRPr sz="1100">
+                <a:solidFill>
+                  <a:srgbClr val="323232"/>
+                </a:solidFill>
+              </a:defRPr>
+            </a:pPr>
+            <a:r>
+              <a:t>3. AI Orchestration Engine: Coordinates multi-agent workflows with error recovery</a:t>
+            </a:r>
+          </a:p>
+          <a:p>
+            <a:pPr>
+              <a:defRPr sz="1100">
+                <a:solidFill>
+                  <a:srgbClr val="323232"/>
+                </a:solidFill>
+              </a:defRPr>
+            </a:pPr>
+            <a:r>
+              <a:t>4. Analytics Dashboard: Real-time ROI tracking powered by Splunk observability</a:t>
+            </a:r>
+          </a:p>
+          <a:p>
+            <a:pPr>
+              <a:defRPr sz="600"/>
+            </a:pPr>
+          </a:p>
+          <a:p>
+            <a:pPr>
+              <a:defRPr sz="1400" b="1">
+                <a:solidFill>
+                  <a:srgbClr val="27AE60"/>
+                </a:solidFill>
+              </a:defRPr>
+            </a:pPr>
+            <a:r>
+              <a:t>Feasibility:</a:t>
+            </a:r>
+          </a:p>
+          <a:p>
+            <a:pPr>
+              <a:defRPr sz="600"/>
+            </a:pPr>
+          </a:p>
+          <a:p>
+            <a:pPr>
+              <a:defRPr sz="1100">
+                <a:solidFill>
+                  <a:srgbClr val="323232"/>
+                </a:solidFill>
+              </a:defRPr>
+            </a:pPr>
+            <a:r>
+              <a:t>Cisco already owns AppDynamics ($3.7B acquisition) + Splunk ($28B) for monitoring</a:t>
+            </a:r>
+          </a:p>
+          <a:p>
+            <a:pPr>
+              <a:defRPr sz="1100">
+                <a:solidFill>
+                  <a:srgbClr val="323232"/>
+                </a:solidFill>
+              </a:defRPr>
+            </a:pPr>
+            <a:r>
+              <a:t>Standard REST/GraphQL APIs available from all major SaaS platforms</a:t>
+            </a:r>
+          </a:p>
+          <a:p>
+            <a:pPr>
+              <a:defRPr sz="1100">
+                <a:solidFill>
+                  <a:srgbClr val="323232"/>
+                </a:solidFill>
+              </a:defRPr>
+            </a:pPr>
+            <a:r>
+              <a:t>Estimated development: 12-18 months for first 50 connectors, scale to 200+</a:t>
+            </a:r>
+          </a:p>
+          <a:p>
+            <a:pPr>
+              <a:defRPr sz="600"/>
+            </a:pPr>
+          </a:p>
+          <a:p>
+            <a:pPr>
+              <a:defRPr sz="1200" b="1">
+                <a:solidFill>
+                  <a:srgbClr val="004FA9"/>
+                </a:solidFill>
+              </a:defRPr>
+            </a:pPr>
+            <a:r>
+              <a:t>SaaS Integration market: $15.6B by 2027 (MarketsandMarkets)</a:t>
+            </a:r>
+          </a:p>
+        </p:txBody>
+      </p:sp>
       <p:sp>
         <p:nvSpPr>
           <p:cNvPr id="5" name="TextBox 4"/>
@@ -6037,6 +6003,198 @@
               </a:defRPr>
             </a:pPr>
             <a:r>
+              <a:t>The Agentic AI Opportunity</a:t>
+            </a:r>
+          </a:p>
+          <a:p>
+            <a:pPr algn="l">
+              <a:defRPr sz="1300">
+                <a:solidFill>
+                  <a:srgbClr val="00BCEB"/>
+                </a:solidFill>
+              </a:defRPr>
+            </a:pPr>
+            <a:r>
+              <a:t>Market Growing from $5.1B to $47B by 2030 (CAGR 44.8%)</a:t>
+            </a:r>
+          </a:p>
+        </p:txBody>
+      </p:sp>
+      <p:sp>
+        <p:nvSpPr>
+          <p:cNvPr id="3" name="Rectangle 2"/>
+          <p:cNvSpPr/>
+          <p:nvPr/>
+        </p:nvSpPr>
+        <p:spPr>
+          <a:xfrm>
+            <a:off x="0" y="1097280"/>
+            <a:ext cx="9144000" cy="45720"/>
+          </a:xfrm>
+          <a:prstGeom prst="rect">
+            <a:avLst/>
+          </a:prstGeom>
+          <a:solidFill>
+            <a:srgbClr val="00BCEB"/>
+          </a:solidFill>
+          <a:ln>
+            <a:noFill/>
+          </a:ln>
+        </p:spPr>
+        <p:style>
+          <a:lnRef idx="1">
+            <a:schemeClr val="accent1"/>
+          </a:lnRef>
+          <a:fillRef idx="3">
+            <a:schemeClr val="accent1"/>
+          </a:fillRef>
+          <a:effectRef idx="2">
+            <a:schemeClr val="accent1"/>
+          </a:effectRef>
+          <a:fontRef idx="minor">
+            <a:schemeClr val="lt1"/>
+          </a:fontRef>
+        </p:style>
+        <p:txBody>
+          <a:bodyPr rtlCol="0" anchor="ctr"/>
+          <a:lstStyle/>
+          <a:p>
+            <a:pPr algn="ctr"/>
+          </a:p>
+        </p:txBody>
+      </p:sp>
+      <p:pic>
+        <p:nvPicPr>
+          <p:cNvPr id="4" name="Picture 3" descr="agentic_market.png"/>
+          <p:cNvPicPr>
+            <a:picLocks noChangeAspect="1"/>
+          </p:cNvPicPr>
+          <p:nvPr/>
+        </p:nvPicPr>
+        <p:blipFill>
+          <a:blip r:embed="rId2"/>
+          <a:stretch>
+            <a:fillRect/>
+          </a:stretch>
+        </p:blipFill>
+        <p:spPr>
+          <a:xfrm>
+            <a:off x="274320" y="1280160"/>
+            <a:ext cx="8595360" cy="5029200"/>
+          </a:xfrm>
+          <a:prstGeom prst="rect">
+            <a:avLst/>
+          </a:prstGeom>
+        </p:spPr>
+      </p:pic>
+      <p:sp>
+        <p:nvSpPr>
+          <p:cNvPr id="5" name="TextBox 4"/>
+          <p:cNvSpPr txBox="1"/>
+          <p:nvPr/>
+        </p:nvSpPr>
+        <p:spPr>
+          <a:xfrm>
+            <a:off x="274320" y="6400800"/>
+            <a:ext cx="8595360" cy="365760"/>
+          </a:xfrm>
+          <a:prstGeom prst="rect">
+            <a:avLst/>
+          </a:prstGeom>
+          <a:noFill/>
+        </p:spPr>
+        <p:txBody>
+          <a:bodyPr wrap="none">
+            <a:spAutoFit/>
+          </a:bodyPr>
+          <a:lstStyle/>
+          <a:p>
+            <a:pPr algn="ctr">
+              <a:defRPr sz="800">
+                <a:solidFill>
+                  <a:srgbClr val="969696"/>
+                </a:solidFill>
+              </a:defRPr>
+            </a:pPr>
+            <a:r>
+              <a:t>Industry Analysis | Problem Identification | Recommendations | Implementation | Financials | Risks | Executive Summary</a:t>
+            </a:r>
+          </a:p>
+        </p:txBody>
+      </p:sp>
+    </p:spTree>
+  </p:cSld>
+  <p:clrMapOvr>
+    <a:masterClrMapping/>
+  </p:clrMapOvr>
+</p:sld>
+</file>
+
+<file path=ppt/slides/slide18.xml><?xml version="1.0" encoding="utf-8"?>
+<p:sld xmlns:a="http://schemas.openxmlformats.org/drawingml/2006/main" xmlns:p="http://schemas.openxmlformats.org/presentationml/2006/main" xmlns:r="http://schemas.openxmlformats.org/officeDocument/2006/relationships">
+  <p:cSld>
+    <p:bg>
+      <p:bgPr>
+        <a:solidFill>
+          <a:srgbClr val="FFFFFF"/>
+        </a:solidFill>
+        <a:effectLst/>
+      </p:bgPr>
+    </p:bg>
+    <p:spTree>
+      <p:nvGrpSpPr>
+        <p:cNvPr id="1" name=""/>
+        <p:cNvGrpSpPr/>
+        <p:nvPr/>
+      </p:nvGrpSpPr>
+      <p:grpSpPr/>
+      <p:sp>
+        <p:nvSpPr>
+          <p:cNvPr id="2" name="Rectangle 1"/>
+          <p:cNvSpPr/>
+          <p:nvPr/>
+        </p:nvSpPr>
+        <p:spPr>
+          <a:xfrm>
+            <a:off x="0" y="0"/>
+            <a:ext cx="9144000" cy="1097280"/>
+          </a:xfrm>
+          <a:prstGeom prst="rect">
+            <a:avLst/>
+          </a:prstGeom>
+          <a:solidFill>
+            <a:srgbClr val="002060"/>
+          </a:solidFill>
+          <a:ln>
+            <a:noFill/>
+          </a:ln>
+        </p:spPr>
+        <p:style>
+          <a:lnRef idx="1">
+            <a:schemeClr val="accent1"/>
+          </a:lnRef>
+          <a:fillRef idx="3">
+            <a:schemeClr val="accent1"/>
+          </a:fillRef>
+          <a:effectRef idx="2">
+            <a:schemeClr val="accent1"/>
+          </a:effectRef>
+          <a:fontRef idx="minor">
+            <a:schemeClr val="lt1"/>
+          </a:fontRef>
+        </p:style>
+        <p:txBody>
+          <a:bodyPr rtlCol="0" anchor="ctr" wrap="square" lIns="457200" tIns="137160"/>
+          <a:lstStyle/>
+          <a:p>
+            <a:pPr algn="l">
+              <a:defRPr sz="2600" b="1">
+                <a:solidFill>
+                  <a:srgbClr val="FFFFFF"/>
+                </a:solidFill>
+              </a:defRPr>
+            </a:pPr>
+            <a:r>
               <a:t>Implementation Timeline</a:t>
             </a:r>
           </a:p>
@@ -6164,7 +6322,7 @@
 </p:sld>
 </file>
 
-<file path=ppt/slides/slide18.xml><?xml version="1.0" encoding="utf-8"?>
+<file path=ppt/slides/slide19.xml><?xml version="1.0" encoding="utf-8"?>
 <p:sld xmlns:a="http://schemas.openxmlformats.org/drawingml/2006/main" xmlns:p="http://schemas.openxmlformats.org/presentationml/2006/main" xmlns:r="http://schemas.openxmlformats.org/officeDocument/2006/relationships">
   <p:cSld>
     <p:bg>
@@ -6784,257 +6942,6 @@
 </p:sld>
 </file>
 
-<file path=ppt/slides/slide19.xml><?xml version="1.0" encoding="utf-8"?>
-<p:sld xmlns:a="http://schemas.openxmlformats.org/drawingml/2006/main" xmlns:p="http://schemas.openxmlformats.org/presentationml/2006/main" xmlns:r="http://schemas.openxmlformats.org/officeDocument/2006/relationships">
-  <p:cSld>
-    <p:bg>
-      <p:bgPr>
-        <a:solidFill>
-          <a:srgbClr val="FFFFFF"/>
-        </a:solidFill>
-        <a:effectLst/>
-      </p:bgPr>
-    </p:bg>
-    <p:spTree>
-      <p:nvGrpSpPr>
-        <p:cNvPr id="1" name=""/>
-        <p:cNvGrpSpPr/>
-        <p:nvPr/>
-      </p:nvGrpSpPr>
-      <p:grpSpPr/>
-      <p:sp>
-        <p:nvSpPr>
-          <p:cNvPr id="2" name="Rectangle 1"/>
-          <p:cNvSpPr/>
-          <p:nvPr/>
-        </p:nvSpPr>
-        <p:spPr>
-          <a:xfrm>
-            <a:off x="0" y="0"/>
-            <a:ext cx="9144000" cy="1097280"/>
-          </a:xfrm>
-          <a:prstGeom prst="rect">
-            <a:avLst/>
-          </a:prstGeom>
-          <a:solidFill>
-            <a:srgbClr val="002060"/>
-          </a:solidFill>
-          <a:ln>
-            <a:noFill/>
-          </a:ln>
-        </p:spPr>
-        <p:style>
-          <a:lnRef idx="1">
-            <a:schemeClr val="accent1"/>
-          </a:lnRef>
-          <a:fillRef idx="3">
-            <a:schemeClr val="accent1"/>
-          </a:fillRef>
-          <a:effectRef idx="2">
-            <a:schemeClr val="accent1"/>
-          </a:effectRef>
-          <a:fontRef idx="minor">
-            <a:schemeClr val="lt1"/>
-          </a:fontRef>
-        </p:style>
-        <p:txBody>
-          <a:bodyPr rtlCol="0" anchor="ctr" wrap="square" lIns="457200" tIns="137160"/>
-          <a:lstStyle/>
-          <a:p>
-            <a:pPr algn="l">
-              <a:defRPr sz="2600" b="1">
-                <a:solidFill>
-                  <a:srgbClr val="FFFFFF"/>
-                </a:solidFill>
-              </a:defRPr>
-            </a:pPr>
-            <a:r>
-              <a:t>Financial Projections</a:t>
-            </a:r>
-          </a:p>
-          <a:p>
-            <a:pPr algn="l">
-              <a:defRPr sz="1300">
-                <a:solidFill>
-                  <a:srgbClr val="00BCEB"/>
-                </a:solidFill>
-              </a:defRPr>
-            </a:pPr>
-            <a:r>
-              <a:t>Projected Revenue Impact of Agentic AI Strategy</a:t>
-            </a:r>
-          </a:p>
-        </p:txBody>
-      </p:sp>
-      <p:sp>
-        <p:nvSpPr>
-          <p:cNvPr id="3" name="Rectangle 2"/>
-          <p:cNvSpPr/>
-          <p:nvPr/>
-        </p:nvSpPr>
-        <p:spPr>
-          <a:xfrm>
-            <a:off x="0" y="1097280"/>
-            <a:ext cx="9144000" cy="45720"/>
-          </a:xfrm>
-          <a:prstGeom prst="rect">
-            <a:avLst/>
-          </a:prstGeom>
-          <a:solidFill>
-            <a:srgbClr val="00BCEB"/>
-          </a:solidFill>
-          <a:ln>
-            <a:noFill/>
-          </a:ln>
-        </p:spPr>
-        <p:style>
-          <a:lnRef idx="1">
-            <a:schemeClr val="accent1"/>
-          </a:lnRef>
-          <a:fillRef idx="3">
-            <a:schemeClr val="accent1"/>
-          </a:fillRef>
-          <a:effectRef idx="2">
-            <a:schemeClr val="accent1"/>
-          </a:effectRef>
-          <a:fontRef idx="minor">
-            <a:schemeClr val="lt1"/>
-          </a:fontRef>
-        </p:style>
-        <p:txBody>
-          <a:bodyPr rtlCol="0" anchor="ctr"/>
-          <a:lstStyle/>
-          <a:p>
-            <a:pPr algn="ctr"/>
-          </a:p>
-        </p:txBody>
-      </p:sp>
-      <p:pic>
-        <p:nvPicPr>
-          <p:cNvPr id="4" name="Picture 3" descr="revenue_projection.png"/>
-          <p:cNvPicPr>
-            <a:picLocks noChangeAspect="1"/>
-          </p:cNvPicPr>
-          <p:nvPr/>
-        </p:nvPicPr>
-        <p:blipFill>
-          <a:blip r:embed="rId2"/>
-          <a:stretch>
-            <a:fillRect/>
-          </a:stretch>
-        </p:blipFill>
-        <p:spPr>
-          <a:xfrm>
-            <a:off x="274320" y="1280160"/>
-            <a:ext cx="8595360" cy="3840480"/>
-          </a:xfrm>
-          <a:prstGeom prst="rect">
-            <a:avLst/>
-          </a:prstGeom>
-        </p:spPr>
-      </p:pic>
-      <p:sp>
-        <p:nvSpPr>
-          <p:cNvPr id="5" name="TextBox 4"/>
-          <p:cNvSpPr txBox="1"/>
-          <p:nvPr/>
-        </p:nvSpPr>
-        <p:spPr>
-          <a:xfrm>
-            <a:off x="457200" y="5212080"/>
-            <a:ext cx="8229600" cy="1371600"/>
-          </a:xfrm>
-          <a:prstGeom prst="rect">
-            <a:avLst/>
-          </a:prstGeom>
-          <a:noFill/>
-        </p:spPr>
-        <p:txBody>
-          <a:bodyPr wrap="square">
-            <a:spAutoFit/>
-          </a:bodyPr>
-          <a:lstStyle/>
-          <a:p>
-            <a:pPr>
-              <a:defRPr sz="1100">
-                <a:solidFill>
-                  <a:srgbClr val="323232"/>
-                </a:solidFill>
-              </a:defRPr>
-            </a:pPr>
-            <a:r>
-              <a:t>Investment: ~$300M over 18 months (from existing $7.98B R&amp;D budget = 3.8% reallocation)</a:t>
-            </a:r>
-          </a:p>
-          <a:p>
-            <a:pPr>
-              <a:defRPr sz="1100">
-                <a:solidFill>
-                  <a:srgbClr val="323232"/>
-                </a:solidFill>
-              </a:defRPr>
-            </a:pPr>
-            <a:r>
-              <a:t>Projected Return: +$2.1B incremental ARR by FY2029 | ROI: ~600% over 4 years</a:t>
-            </a:r>
-          </a:p>
-          <a:p>
-            <a:pPr>
-              <a:defRPr sz="1000" b="0">
-                <a:solidFill>
-                  <a:srgbClr val="646464"/>
-                </a:solidFill>
-              </a:defRPr>
-            </a:pPr>
-            <a:r>
-              <a:t>Based on IDC UC&amp;C CAGR 8.4% + estimated 3-5% market share gain from agentic differentiation</a:t>
-            </a:r>
-          </a:p>
-        </p:txBody>
-      </p:sp>
-      <p:sp>
-        <p:nvSpPr>
-          <p:cNvPr id="6" name="TextBox 5"/>
-          <p:cNvSpPr txBox="1"/>
-          <p:nvPr/>
-        </p:nvSpPr>
-        <p:spPr>
-          <a:xfrm>
-            <a:off x="274320" y="6400800"/>
-            <a:ext cx="8595360" cy="365760"/>
-          </a:xfrm>
-          <a:prstGeom prst="rect">
-            <a:avLst/>
-          </a:prstGeom>
-          <a:noFill/>
-        </p:spPr>
-        <p:txBody>
-          <a:bodyPr wrap="none">
-            <a:spAutoFit/>
-          </a:bodyPr>
-          <a:lstStyle/>
-          <a:p>
-            <a:pPr algn="ctr">
-              <a:defRPr sz="800">
-                <a:solidFill>
-                  <a:srgbClr val="969696"/>
-                </a:solidFill>
-              </a:defRPr>
-            </a:pPr>
-            <a:r>
-              <a:t>Industry Analysis | Problem Identification | Recommendations | Implementation | Financials | Risks | Executive Summary</a:t>
-            </a:r>
-          </a:p>
-        </p:txBody>
-      </p:sp>
-    </p:spTree>
-  </p:cSld>
-  <p:clrMapOvr>
-    <a:masterClrMapping/>
-  </p:clrMapOvr>
-</p:sld>
-</file>
-
 <file path=ppt/slides/slide2.xml><?xml version="1.0" encoding="utf-8"?>
 <p:sld xmlns:a="http://schemas.openxmlformats.org/drawingml/2006/main" xmlns:p="http://schemas.openxmlformats.org/presentationml/2006/main" xmlns:r="http://schemas.openxmlformats.org/officeDocument/2006/relationships">
   <p:cSld>
@@ -7393,6 +7300,257 @@
               </a:defRPr>
             </a:pPr>
             <a:r>
+              <a:t>Financial Projections</a:t>
+            </a:r>
+          </a:p>
+          <a:p>
+            <a:pPr algn="l">
+              <a:defRPr sz="1300">
+                <a:solidFill>
+                  <a:srgbClr val="00BCEB"/>
+                </a:solidFill>
+              </a:defRPr>
+            </a:pPr>
+            <a:r>
+              <a:t>Projected Revenue Impact of Agentic AI Strategy</a:t>
+            </a:r>
+          </a:p>
+        </p:txBody>
+      </p:sp>
+      <p:sp>
+        <p:nvSpPr>
+          <p:cNvPr id="3" name="Rectangle 2"/>
+          <p:cNvSpPr/>
+          <p:nvPr/>
+        </p:nvSpPr>
+        <p:spPr>
+          <a:xfrm>
+            <a:off x="0" y="1097280"/>
+            <a:ext cx="9144000" cy="45720"/>
+          </a:xfrm>
+          <a:prstGeom prst="rect">
+            <a:avLst/>
+          </a:prstGeom>
+          <a:solidFill>
+            <a:srgbClr val="00BCEB"/>
+          </a:solidFill>
+          <a:ln>
+            <a:noFill/>
+          </a:ln>
+        </p:spPr>
+        <p:style>
+          <a:lnRef idx="1">
+            <a:schemeClr val="accent1"/>
+          </a:lnRef>
+          <a:fillRef idx="3">
+            <a:schemeClr val="accent1"/>
+          </a:fillRef>
+          <a:effectRef idx="2">
+            <a:schemeClr val="accent1"/>
+          </a:effectRef>
+          <a:fontRef idx="minor">
+            <a:schemeClr val="lt1"/>
+          </a:fontRef>
+        </p:style>
+        <p:txBody>
+          <a:bodyPr rtlCol="0" anchor="ctr"/>
+          <a:lstStyle/>
+          <a:p>
+            <a:pPr algn="ctr"/>
+          </a:p>
+        </p:txBody>
+      </p:sp>
+      <p:pic>
+        <p:nvPicPr>
+          <p:cNvPr id="4" name="Picture 3" descr="revenue_projection.png"/>
+          <p:cNvPicPr>
+            <a:picLocks noChangeAspect="1"/>
+          </p:cNvPicPr>
+          <p:nvPr/>
+        </p:nvPicPr>
+        <p:blipFill>
+          <a:blip r:embed="rId2"/>
+          <a:stretch>
+            <a:fillRect/>
+          </a:stretch>
+        </p:blipFill>
+        <p:spPr>
+          <a:xfrm>
+            <a:off x="274320" y="1280160"/>
+            <a:ext cx="8595360" cy="3840480"/>
+          </a:xfrm>
+          <a:prstGeom prst="rect">
+            <a:avLst/>
+          </a:prstGeom>
+        </p:spPr>
+      </p:pic>
+      <p:sp>
+        <p:nvSpPr>
+          <p:cNvPr id="5" name="TextBox 4"/>
+          <p:cNvSpPr txBox="1"/>
+          <p:nvPr/>
+        </p:nvSpPr>
+        <p:spPr>
+          <a:xfrm>
+            <a:off x="457200" y="5212080"/>
+            <a:ext cx="8229600" cy="1371600"/>
+          </a:xfrm>
+          <a:prstGeom prst="rect">
+            <a:avLst/>
+          </a:prstGeom>
+          <a:noFill/>
+        </p:spPr>
+        <p:txBody>
+          <a:bodyPr wrap="square">
+            <a:spAutoFit/>
+          </a:bodyPr>
+          <a:lstStyle/>
+          <a:p>
+            <a:pPr>
+              <a:defRPr sz="1100">
+                <a:solidFill>
+                  <a:srgbClr val="323232"/>
+                </a:solidFill>
+              </a:defRPr>
+            </a:pPr>
+            <a:r>
+              <a:t>Investment: ~$300M over 18 months (from existing $7.98B R&amp;D budget = 3.8% reallocation)</a:t>
+            </a:r>
+          </a:p>
+          <a:p>
+            <a:pPr>
+              <a:defRPr sz="1100">
+                <a:solidFill>
+                  <a:srgbClr val="323232"/>
+                </a:solidFill>
+              </a:defRPr>
+            </a:pPr>
+            <a:r>
+              <a:t>Projected Return: +$2.1B incremental ARR by FY2029 | ROI: ~600% over 4 years</a:t>
+            </a:r>
+          </a:p>
+          <a:p>
+            <a:pPr>
+              <a:defRPr sz="1000" b="0">
+                <a:solidFill>
+                  <a:srgbClr val="646464"/>
+                </a:solidFill>
+              </a:defRPr>
+            </a:pPr>
+            <a:r>
+              <a:t>Based on IDC UC&amp;C CAGR 8.4% + estimated 3-5% market share gain from agentic differentiation</a:t>
+            </a:r>
+          </a:p>
+        </p:txBody>
+      </p:sp>
+      <p:sp>
+        <p:nvSpPr>
+          <p:cNvPr id="6" name="TextBox 5"/>
+          <p:cNvSpPr txBox="1"/>
+          <p:nvPr/>
+        </p:nvSpPr>
+        <p:spPr>
+          <a:xfrm>
+            <a:off x="274320" y="6400800"/>
+            <a:ext cx="8595360" cy="365760"/>
+          </a:xfrm>
+          <a:prstGeom prst="rect">
+            <a:avLst/>
+          </a:prstGeom>
+          <a:noFill/>
+        </p:spPr>
+        <p:txBody>
+          <a:bodyPr wrap="none">
+            <a:spAutoFit/>
+          </a:bodyPr>
+          <a:lstStyle/>
+          <a:p>
+            <a:pPr algn="ctr">
+              <a:defRPr sz="800">
+                <a:solidFill>
+                  <a:srgbClr val="969696"/>
+                </a:solidFill>
+              </a:defRPr>
+            </a:pPr>
+            <a:r>
+              <a:t>Industry Analysis | Problem Identification | Recommendations | Implementation | Financials | Risks | Executive Summary</a:t>
+            </a:r>
+          </a:p>
+        </p:txBody>
+      </p:sp>
+    </p:spTree>
+  </p:cSld>
+  <p:clrMapOvr>
+    <a:masterClrMapping/>
+  </p:clrMapOvr>
+</p:sld>
+</file>
+
+<file path=ppt/slides/slide21.xml><?xml version="1.0" encoding="utf-8"?>
+<p:sld xmlns:a="http://schemas.openxmlformats.org/drawingml/2006/main" xmlns:p="http://schemas.openxmlformats.org/presentationml/2006/main" xmlns:r="http://schemas.openxmlformats.org/officeDocument/2006/relationships">
+  <p:cSld>
+    <p:bg>
+      <p:bgPr>
+        <a:solidFill>
+          <a:srgbClr val="FFFFFF"/>
+        </a:solidFill>
+        <a:effectLst/>
+      </p:bgPr>
+    </p:bg>
+    <p:spTree>
+      <p:nvGrpSpPr>
+        <p:cNvPr id="1" name=""/>
+        <p:cNvGrpSpPr/>
+        <p:nvPr/>
+      </p:nvGrpSpPr>
+      <p:grpSpPr/>
+      <p:sp>
+        <p:nvSpPr>
+          <p:cNvPr id="2" name="Rectangle 1"/>
+          <p:cNvSpPr/>
+          <p:nvPr/>
+        </p:nvSpPr>
+        <p:spPr>
+          <a:xfrm>
+            <a:off x="0" y="0"/>
+            <a:ext cx="9144000" cy="1097280"/>
+          </a:xfrm>
+          <a:prstGeom prst="rect">
+            <a:avLst/>
+          </a:prstGeom>
+          <a:solidFill>
+            <a:srgbClr val="002060"/>
+          </a:solidFill>
+          <a:ln>
+            <a:noFill/>
+          </a:ln>
+        </p:spPr>
+        <p:style>
+          <a:lnRef idx="1">
+            <a:schemeClr val="accent1"/>
+          </a:lnRef>
+          <a:fillRef idx="3">
+            <a:schemeClr val="accent1"/>
+          </a:fillRef>
+          <a:effectRef idx="2">
+            <a:schemeClr val="accent1"/>
+          </a:effectRef>
+          <a:fontRef idx="minor">
+            <a:schemeClr val="lt1"/>
+          </a:fontRef>
+        </p:style>
+        <p:txBody>
+          <a:bodyPr rtlCol="0" anchor="ctr" wrap="square" lIns="457200" tIns="137160"/>
+          <a:lstStyle/>
+          <a:p>
+            <a:pPr algn="l">
+              <a:defRPr sz="2600" b="1">
+                <a:solidFill>
+                  <a:srgbClr val="FFFFFF"/>
+                </a:solidFill>
+              </a:defRPr>
+            </a:pPr>
+            <a:r>
               <a:t>Key Performance Indicators</a:t>
             </a:r>
           </a:p>
@@ -7913,7 +8071,7 @@
 </p:sld>
 </file>
 
-<file path=ppt/slides/slide21.xml><?xml version="1.0" encoding="utf-8"?>
+<file path=ppt/slides/slide22.xml><?xml version="1.0" encoding="utf-8"?>
 <p:sld xmlns:a="http://schemas.openxmlformats.org/drawingml/2006/main" xmlns:p="http://schemas.openxmlformats.org/presentationml/2006/main" xmlns:r="http://schemas.openxmlformats.org/officeDocument/2006/relationships">
   <p:cSld>
     <p:bg>
@@ -8567,356 +8725,6 @@
 </p:sld>
 </file>
 
-<file path=ppt/slides/slide22.xml><?xml version="1.0" encoding="utf-8"?>
-<p:sld xmlns:a="http://schemas.openxmlformats.org/drawingml/2006/main" xmlns:p="http://schemas.openxmlformats.org/presentationml/2006/main" xmlns:r="http://schemas.openxmlformats.org/officeDocument/2006/relationships">
-  <p:cSld>
-    <p:bg>
-      <p:bgPr>
-        <a:solidFill>
-          <a:srgbClr val="FFFFFF"/>
-        </a:solidFill>
-        <a:effectLst/>
-      </p:bgPr>
-    </p:bg>
-    <p:spTree>
-      <p:nvGrpSpPr>
-        <p:cNvPr id="1" name=""/>
-        <p:cNvGrpSpPr/>
-        <p:nvPr/>
-      </p:nvGrpSpPr>
-      <p:grpSpPr/>
-      <p:sp>
-        <p:nvSpPr>
-          <p:cNvPr id="2" name="Rectangle 1"/>
-          <p:cNvSpPr/>
-          <p:nvPr/>
-        </p:nvSpPr>
-        <p:spPr>
-          <a:xfrm>
-            <a:off x="0" y="0"/>
-            <a:ext cx="9144000" cy="1097280"/>
-          </a:xfrm>
-          <a:prstGeom prst="rect">
-            <a:avLst/>
-          </a:prstGeom>
-          <a:solidFill>
-            <a:srgbClr val="002060"/>
-          </a:solidFill>
-          <a:ln>
-            <a:noFill/>
-          </a:ln>
-        </p:spPr>
-        <p:style>
-          <a:lnRef idx="1">
-            <a:schemeClr val="accent1"/>
-          </a:lnRef>
-          <a:fillRef idx="3">
-            <a:schemeClr val="accent1"/>
-          </a:fillRef>
-          <a:effectRef idx="2">
-            <a:schemeClr val="accent1"/>
-          </a:effectRef>
-          <a:fontRef idx="minor">
-            <a:schemeClr val="lt1"/>
-          </a:fontRef>
-        </p:style>
-        <p:txBody>
-          <a:bodyPr rtlCol="0" anchor="ctr" wrap="square" lIns="457200" tIns="137160"/>
-          <a:lstStyle/>
-          <a:p>
-            <a:pPr algn="l">
-              <a:defRPr sz="2600" b="1">
-                <a:solidFill>
-                  <a:srgbClr val="FFFFFF"/>
-                </a:solidFill>
-              </a:defRPr>
-            </a:pPr>
-            <a:r>
-              <a:t>Engineering Trade-offs &amp; Constraints</a:t>
-            </a:r>
-          </a:p>
-          <a:p>
-            <a:pPr algn="l">
-              <a:defRPr sz="1300">
-                <a:solidFill>
-                  <a:srgbClr val="00BCEB"/>
-                </a:solidFill>
-              </a:defRPr>
-            </a:pPr>
-            <a:r>
-              <a:t>Watson College Engineering Analysis</a:t>
-            </a:r>
-          </a:p>
-        </p:txBody>
-      </p:sp>
-      <p:sp>
-        <p:nvSpPr>
-          <p:cNvPr id="3" name="Rectangle 2"/>
-          <p:cNvSpPr/>
-          <p:nvPr/>
-        </p:nvSpPr>
-        <p:spPr>
-          <a:xfrm>
-            <a:off x="0" y="1097280"/>
-            <a:ext cx="9144000" cy="45720"/>
-          </a:xfrm>
-          <a:prstGeom prst="rect">
-            <a:avLst/>
-          </a:prstGeom>
-          <a:solidFill>
-            <a:srgbClr val="00BCEB"/>
-          </a:solidFill>
-          <a:ln>
-            <a:noFill/>
-          </a:ln>
-        </p:spPr>
-        <p:style>
-          <a:lnRef idx="1">
-            <a:schemeClr val="accent1"/>
-          </a:lnRef>
-          <a:fillRef idx="3">
-            <a:schemeClr val="accent1"/>
-          </a:fillRef>
-          <a:effectRef idx="2">
-            <a:schemeClr val="accent1"/>
-          </a:effectRef>
-          <a:fontRef idx="minor">
-            <a:schemeClr val="lt1"/>
-          </a:fontRef>
-        </p:style>
-        <p:txBody>
-          <a:bodyPr rtlCol="0" anchor="ctr"/>
-          <a:lstStyle/>
-          <a:p>
-            <a:pPr algn="ctr"/>
-          </a:p>
-        </p:txBody>
-      </p:sp>
-      <p:sp>
-        <p:nvSpPr>
-          <p:cNvPr id="4" name="TextBox 3"/>
-          <p:cNvSpPr txBox="1"/>
-          <p:nvPr/>
-        </p:nvSpPr>
-        <p:spPr>
-          <a:xfrm>
-            <a:off x="457200" y="1371600"/>
-            <a:ext cx="8229600" cy="5029200"/>
-          </a:xfrm>
-          <a:prstGeom prst="rect">
-            <a:avLst/>
-          </a:prstGeom>
-          <a:noFill/>
-        </p:spPr>
-        <p:txBody>
-          <a:bodyPr wrap="square">
-            <a:spAutoFit/>
-          </a:bodyPr>
-          <a:lstStyle/>
-          <a:p>
-            <a:pPr>
-              <a:defRPr sz="1400" b="1">
-                <a:solidFill>
-                  <a:srgbClr val="002060"/>
-                </a:solidFill>
-              </a:defRPr>
-            </a:pPr>
-            <a:r>
-              <a:t>Autonomy vs. Control</a:t>
-            </a:r>
-          </a:p>
-          <a:p>
-            <a:pPr>
-              <a:defRPr sz="1200">
-                <a:solidFill>
-                  <a:srgbClr val="323232"/>
-                </a:solidFill>
-              </a:defRPr>
-            </a:pPr>
-            <a:r>
-              <a:t>More agentic capability increases productivity but raises risk of unintended actions</a:t>
-            </a:r>
-          </a:p>
-          <a:p>
-            <a:pPr>
-              <a:defRPr sz="1200">
-                <a:solidFill>
-                  <a:srgbClr val="323232"/>
-                </a:solidFill>
-              </a:defRPr>
-            </a:pPr>
-            <a:r>
-              <a:t>Solution: Configurable autonomy levels (low / medium / high) per organization</a:t>
-            </a:r>
-          </a:p>
-          <a:p>
-            <a:pPr>
-              <a:defRPr sz="600"/>
-            </a:pPr>
-          </a:p>
-          <a:p>
-            <a:pPr>
-              <a:defRPr sz="1400" b="1">
-                <a:solidFill>
-                  <a:srgbClr val="002060"/>
-                </a:solidFill>
-              </a:defRPr>
-            </a:pPr>
-            <a:r>
-              <a:t>Open Platform vs. Security</a:t>
-            </a:r>
-          </a:p>
-          <a:p>
-            <a:pPr>
-              <a:defRPr sz="1200">
-                <a:solidFill>
-                  <a:srgbClr val="323232"/>
-                </a:solidFill>
-              </a:defRPr>
-            </a:pPr>
-            <a:r>
-              <a:t>Open Agent SDK increases ecosystem growth but expands attack surface</a:t>
-            </a:r>
-          </a:p>
-          <a:p>
-            <a:pPr>
-              <a:defRPr sz="1200">
-                <a:solidFill>
-                  <a:srgbClr val="323232"/>
-                </a:solidFill>
-              </a:defRPr>
-            </a:pPr>
-            <a:r>
-              <a:t>Solution: Sandboxed execution + mandatory security review for marketplace agents</a:t>
-            </a:r>
-          </a:p>
-          <a:p>
-            <a:pPr>
-              <a:defRPr sz="600"/>
-            </a:pPr>
-          </a:p>
-          <a:p>
-            <a:pPr>
-              <a:defRPr sz="1400" b="1">
-                <a:solidFill>
-                  <a:srgbClr val="002060"/>
-                </a:solidFill>
-              </a:defRPr>
-            </a:pPr>
-            <a:r>
-              <a:t>Build vs. Buy for Workflow Engine</a:t>
-            </a:r>
-          </a:p>
-          <a:p>
-            <a:pPr>
-              <a:defRPr sz="1200">
-                <a:solidFill>
-                  <a:srgbClr val="323232"/>
-                </a:solidFill>
-              </a:defRPr>
-            </a:pPr>
-            <a:r>
-              <a:t>Building in-house ensures deep integration; acquiring iPaaS is faster</a:t>
-            </a:r>
-          </a:p>
-          <a:p>
-            <a:pPr>
-              <a:defRPr sz="1200">
-                <a:solidFill>
-                  <a:srgbClr val="323232"/>
-                </a:solidFill>
-              </a:defRPr>
-            </a:pPr>
-            <a:r>
-              <a:t>Solution: Hybrid -- build AI orchestration layer, partner for connector framework</a:t>
-            </a:r>
-          </a:p>
-          <a:p>
-            <a:pPr>
-              <a:defRPr sz="600"/>
-            </a:pPr>
-          </a:p>
-          <a:p>
-            <a:pPr>
-              <a:defRPr sz="1400" b="1">
-                <a:solidFill>
-                  <a:srgbClr val="002060"/>
-                </a:solidFill>
-              </a:defRPr>
-            </a:pPr>
-            <a:r>
-              <a:t>Latency Constraint</a:t>
-            </a:r>
-          </a:p>
-          <a:p>
-            <a:pPr>
-              <a:defRPr sz="1200">
-                <a:solidFill>
-                  <a:srgbClr val="323232"/>
-                </a:solidFill>
-              </a:defRPr>
-            </a:pPr>
-            <a:r>
-              <a:t>Agentic tasks must complete within 2-5 seconds for user satisfaction</a:t>
-            </a:r>
-          </a:p>
-          <a:p>
-            <a:pPr>
-              <a:defRPr sz="1200">
-                <a:solidFill>
-                  <a:srgbClr val="323232"/>
-                </a:solidFill>
-              </a:defRPr>
-            </a:pPr>
-            <a:r>
-              <a:t>Multi-tool workflows may exceed this; use async execution with real-time updates</a:t>
-            </a:r>
-          </a:p>
-        </p:txBody>
-      </p:sp>
-      <p:sp>
-        <p:nvSpPr>
-          <p:cNvPr id="5" name="TextBox 4"/>
-          <p:cNvSpPr txBox="1"/>
-          <p:nvPr/>
-        </p:nvSpPr>
-        <p:spPr>
-          <a:xfrm>
-            <a:off x="274320" y="6400800"/>
-            <a:ext cx="8595360" cy="365760"/>
-          </a:xfrm>
-          <a:prstGeom prst="rect">
-            <a:avLst/>
-          </a:prstGeom>
-          <a:noFill/>
-        </p:spPr>
-        <p:txBody>
-          <a:bodyPr wrap="none">
-            <a:spAutoFit/>
-          </a:bodyPr>
-          <a:lstStyle/>
-          <a:p>
-            <a:pPr algn="ctr">
-              <a:defRPr sz="800">
-                <a:solidFill>
-                  <a:srgbClr val="969696"/>
-                </a:solidFill>
-              </a:defRPr>
-            </a:pPr>
-            <a:r>
-              <a:t>Industry Analysis | Problem Identification | Recommendations | Implementation | Financials | Risks | Executive Summary</a:t>
-            </a:r>
-          </a:p>
-        </p:txBody>
-      </p:sp>
-    </p:spTree>
-  </p:cSld>
-  <p:clrMapOvr>
-    <a:masterClrMapping/>
-  </p:clrMapOvr>
-</p:sld>
-</file>
-
 <file path=ppt/slides/slide23.xml><?xml version="1.0" encoding="utf-8"?>
 <p:sld xmlns:a="http://schemas.openxmlformats.org/drawingml/2006/main" xmlns:p="http://schemas.openxmlformats.org/presentationml/2006/main" xmlns:r="http://schemas.openxmlformats.org/officeDocument/2006/relationships">
   <p:cSld>
@@ -8982,6 +8790,356 @@
               </a:defRPr>
             </a:pPr>
             <a:r>
+              <a:t>Engineering Trade-offs &amp; Constraints</a:t>
+            </a:r>
+          </a:p>
+          <a:p>
+            <a:pPr algn="l">
+              <a:defRPr sz="1300">
+                <a:solidFill>
+                  <a:srgbClr val="00BCEB"/>
+                </a:solidFill>
+              </a:defRPr>
+            </a:pPr>
+            <a:r>
+              <a:t>Watson College Engineering Analysis</a:t>
+            </a:r>
+          </a:p>
+        </p:txBody>
+      </p:sp>
+      <p:sp>
+        <p:nvSpPr>
+          <p:cNvPr id="3" name="Rectangle 2"/>
+          <p:cNvSpPr/>
+          <p:nvPr/>
+        </p:nvSpPr>
+        <p:spPr>
+          <a:xfrm>
+            <a:off x="0" y="1097280"/>
+            <a:ext cx="9144000" cy="45720"/>
+          </a:xfrm>
+          <a:prstGeom prst="rect">
+            <a:avLst/>
+          </a:prstGeom>
+          <a:solidFill>
+            <a:srgbClr val="00BCEB"/>
+          </a:solidFill>
+          <a:ln>
+            <a:noFill/>
+          </a:ln>
+        </p:spPr>
+        <p:style>
+          <a:lnRef idx="1">
+            <a:schemeClr val="accent1"/>
+          </a:lnRef>
+          <a:fillRef idx="3">
+            <a:schemeClr val="accent1"/>
+          </a:fillRef>
+          <a:effectRef idx="2">
+            <a:schemeClr val="accent1"/>
+          </a:effectRef>
+          <a:fontRef idx="minor">
+            <a:schemeClr val="lt1"/>
+          </a:fontRef>
+        </p:style>
+        <p:txBody>
+          <a:bodyPr rtlCol="0" anchor="ctr"/>
+          <a:lstStyle/>
+          <a:p>
+            <a:pPr algn="ctr"/>
+          </a:p>
+        </p:txBody>
+      </p:sp>
+      <p:sp>
+        <p:nvSpPr>
+          <p:cNvPr id="4" name="TextBox 3"/>
+          <p:cNvSpPr txBox="1"/>
+          <p:nvPr/>
+        </p:nvSpPr>
+        <p:spPr>
+          <a:xfrm>
+            <a:off x="457200" y="1371600"/>
+            <a:ext cx="8229600" cy="5029200"/>
+          </a:xfrm>
+          <a:prstGeom prst="rect">
+            <a:avLst/>
+          </a:prstGeom>
+          <a:noFill/>
+        </p:spPr>
+        <p:txBody>
+          <a:bodyPr wrap="square">
+            <a:spAutoFit/>
+          </a:bodyPr>
+          <a:lstStyle/>
+          <a:p>
+            <a:pPr>
+              <a:defRPr sz="1400" b="1">
+                <a:solidFill>
+                  <a:srgbClr val="002060"/>
+                </a:solidFill>
+              </a:defRPr>
+            </a:pPr>
+            <a:r>
+              <a:t>Autonomy vs. Control</a:t>
+            </a:r>
+          </a:p>
+          <a:p>
+            <a:pPr>
+              <a:defRPr sz="1200">
+                <a:solidFill>
+                  <a:srgbClr val="323232"/>
+                </a:solidFill>
+              </a:defRPr>
+            </a:pPr>
+            <a:r>
+              <a:t>More agentic capability increases productivity but raises risk of unintended actions</a:t>
+            </a:r>
+          </a:p>
+          <a:p>
+            <a:pPr>
+              <a:defRPr sz="1200">
+                <a:solidFill>
+                  <a:srgbClr val="323232"/>
+                </a:solidFill>
+              </a:defRPr>
+            </a:pPr>
+            <a:r>
+              <a:t>Solution: Configurable autonomy levels (low / medium / high) per organization</a:t>
+            </a:r>
+          </a:p>
+          <a:p>
+            <a:pPr>
+              <a:defRPr sz="600"/>
+            </a:pPr>
+          </a:p>
+          <a:p>
+            <a:pPr>
+              <a:defRPr sz="1400" b="1">
+                <a:solidFill>
+                  <a:srgbClr val="002060"/>
+                </a:solidFill>
+              </a:defRPr>
+            </a:pPr>
+            <a:r>
+              <a:t>Open Platform vs. Security</a:t>
+            </a:r>
+          </a:p>
+          <a:p>
+            <a:pPr>
+              <a:defRPr sz="1200">
+                <a:solidFill>
+                  <a:srgbClr val="323232"/>
+                </a:solidFill>
+              </a:defRPr>
+            </a:pPr>
+            <a:r>
+              <a:t>Open Agent SDK increases ecosystem growth but expands attack surface</a:t>
+            </a:r>
+          </a:p>
+          <a:p>
+            <a:pPr>
+              <a:defRPr sz="1200">
+                <a:solidFill>
+                  <a:srgbClr val="323232"/>
+                </a:solidFill>
+              </a:defRPr>
+            </a:pPr>
+            <a:r>
+              <a:t>Solution: Sandboxed execution + mandatory security review for marketplace agents</a:t>
+            </a:r>
+          </a:p>
+          <a:p>
+            <a:pPr>
+              <a:defRPr sz="600"/>
+            </a:pPr>
+          </a:p>
+          <a:p>
+            <a:pPr>
+              <a:defRPr sz="1400" b="1">
+                <a:solidFill>
+                  <a:srgbClr val="002060"/>
+                </a:solidFill>
+              </a:defRPr>
+            </a:pPr>
+            <a:r>
+              <a:t>Build vs. Buy for Workflow Engine</a:t>
+            </a:r>
+          </a:p>
+          <a:p>
+            <a:pPr>
+              <a:defRPr sz="1200">
+                <a:solidFill>
+                  <a:srgbClr val="323232"/>
+                </a:solidFill>
+              </a:defRPr>
+            </a:pPr>
+            <a:r>
+              <a:t>Building in-house ensures deep integration; acquiring iPaaS is faster</a:t>
+            </a:r>
+          </a:p>
+          <a:p>
+            <a:pPr>
+              <a:defRPr sz="1200">
+                <a:solidFill>
+                  <a:srgbClr val="323232"/>
+                </a:solidFill>
+              </a:defRPr>
+            </a:pPr>
+            <a:r>
+              <a:t>Solution: Hybrid -- build AI orchestration layer, partner for connector framework</a:t>
+            </a:r>
+          </a:p>
+          <a:p>
+            <a:pPr>
+              <a:defRPr sz="600"/>
+            </a:pPr>
+          </a:p>
+          <a:p>
+            <a:pPr>
+              <a:defRPr sz="1400" b="1">
+                <a:solidFill>
+                  <a:srgbClr val="002060"/>
+                </a:solidFill>
+              </a:defRPr>
+            </a:pPr>
+            <a:r>
+              <a:t>Latency Constraint</a:t>
+            </a:r>
+          </a:p>
+          <a:p>
+            <a:pPr>
+              <a:defRPr sz="1200">
+                <a:solidFill>
+                  <a:srgbClr val="323232"/>
+                </a:solidFill>
+              </a:defRPr>
+            </a:pPr>
+            <a:r>
+              <a:t>Agentic tasks must complete within 2-5 seconds for user satisfaction</a:t>
+            </a:r>
+          </a:p>
+          <a:p>
+            <a:pPr>
+              <a:defRPr sz="1200">
+                <a:solidFill>
+                  <a:srgbClr val="323232"/>
+                </a:solidFill>
+              </a:defRPr>
+            </a:pPr>
+            <a:r>
+              <a:t>Multi-tool workflows may exceed this; use async execution with real-time updates</a:t>
+            </a:r>
+          </a:p>
+        </p:txBody>
+      </p:sp>
+      <p:sp>
+        <p:nvSpPr>
+          <p:cNvPr id="5" name="TextBox 4"/>
+          <p:cNvSpPr txBox="1"/>
+          <p:nvPr/>
+        </p:nvSpPr>
+        <p:spPr>
+          <a:xfrm>
+            <a:off x="274320" y="6400800"/>
+            <a:ext cx="8595360" cy="365760"/>
+          </a:xfrm>
+          <a:prstGeom prst="rect">
+            <a:avLst/>
+          </a:prstGeom>
+          <a:noFill/>
+        </p:spPr>
+        <p:txBody>
+          <a:bodyPr wrap="none">
+            <a:spAutoFit/>
+          </a:bodyPr>
+          <a:lstStyle/>
+          <a:p>
+            <a:pPr algn="ctr">
+              <a:defRPr sz="800">
+                <a:solidFill>
+                  <a:srgbClr val="969696"/>
+                </a:solidFill>
+              </a:defRPr>
+            </a:pPr>
+            <a:r>
+              <a:t>Industry Analysis | Problem Identification | Recommendations | Implementation | Financials | Risks | Executive Summary</a:t>
+            </a:r>
+          </a:p>
+        </p:txBody>
+      </p:sp>
+    </p:spTree>
+  </p:cSld>
+  <p:clrMapOvr>
+    <a:masterClrMapping/>
+  </p:clrMapOvr>
+</p:sld>
+</file>
+
+<file path=ppt/slides/slide24.xml><?xml version="1.0" encoding="utf-8"?>
+<p:sld xmlns:a="http://schemas.openxmlformats.org/drawingml/2006/main" xmlns:p="http://schemas.openxmlformats.org/presentationml/2006/main" xmlns:r="http://schemas.openxmlformats.org/officeDocument/2006/relationships">
+  <p:cSld>
+    <p:bg>
+      <p:bgPr>
+        <a:solidFill>
+          <a:srgbClr val="FFFFFF"/>
+        </a:solidFill>
+        <a:effectLst/>
+      </p:bgPr>
+    </p:bg>
+    <p:spTree>
+      <p:nvGrpSpPr>
+        <p:cNvPr id="1" name=""/>
+        <p:cNvGrpSpPr/>
+        <p:nvPr/>
+      </p:nvGrpSpPr>
+      <p:grpSpPr/>
+      <p:sp>
+        <p:nvSpPr>
+          <p:cNvPr id="2" name="Rectangle 1"/>
+          <p:cNvSpPr/>
+          <p:nvPr/>
+        </p:nvSpPr>
+        <p:spPr>
+          <a:xfrm>
+            <a:off x="0" y="0"/>
+            <a:ext cx="9144000" cy="1097280"/>
+          </a:xfrm>
+          <a:prstGeom prst="rect">
+            <a:avLst/>
+          </a:prstGeom>
+          <a:solidFill>
+            <a:srgbClr val="002060"/>
+          </a:solidFill>
+          <a:ln>
+            <a:noFill/>
+          </a:ln>
+        </p:spPr>
+        <p:style>
+          <a:lnRef idx="1">
+            <a:schemeClr val="accent1"/>
+          </a:lnRef>
+          <a:fillRef idx="3">
+            <a:schemeClr val="accent1"/>
+          </a:fillRef>
+          <a:effectRef idx="2">
+            <a:schemeClr val="accent1"/>
+          </a:effectRef>
+          <a:fontRef idx="minor">
+            <a:schemeClr val="lt1"/>
+          </a:fontRef>
+        </p:style>
+        <p:txBody>
+          <a:bodyPr rtlCol="0" anchor="ctr" wrap="square" lIns="457200" tIns="137160"/>
+          <a:lstStyle/>
+          <a:p>
+            <a:pPr algn="l">
+              <a:defRPr sz="2600" b="1">
+                <a:solidFill>
+                  <a:srgbClr val="FFFFFF"/>
+                </a:solidFill>
+              </a:defRPr>
+            </a:pPr>
+            <a:r>
               <a:t>Executive Summary</a:t>
             </a:r>
           </a:p>
@@ -9468,7 +9626,7 @@
 </p:sld>
 </file>
 
-<file path=ppt/slides/slide24.xml><?xml version="1.0" encoding="utf-8"?>
+<file path=ppt/slides/slide25.xml><?xml version="1.0" encoding="utf-8"?>
 <p:sld xmlns:a="http://schemas.openxmlformats.org/drawingml/2006/main" xmlns:p="http://schemas.openxmlformats.org/presentationml/2006/main" xmlns:r="http://schemas.openxmlformats.org/officeDocument/2006/relationships">
   <p:cSld>
     <p:bg>
@@ -10145,7 +10303,7 @@
 </p:sld>
 </file>
 
-<file path=ppt/slides/slide25.xml><?xml version="1.0" encoding="utf-8"?>
+<file path=ppt/slides/slide26.xml><?xml version="1.0" encoding="utf-8"?>
 <p:sld xmlns:a="http://schemas.openxmlformats.org/drawingml/2006/main" xmlns:p="http://schemas.openxmlformats.org/presentationml/2006/main" xmlns:r="http://schemas.openxmlformats.org/officeDocument/2006/relationships">
   <p:cSld>
     <p:bg>

</xml_diff>